<commit_message>
Deck: remove empty chart values and the invalid dash value that made PowerPoint repair the file and drop slide 1 (D72)
Co-Authored-By: Claude Opus 5.5 <noreply@anthropic.com>
</commit_message>
<xml_diff>
--- a/deck/deck.pptx
+++ b/deck/deck.pptx
@@ -111,27 +111,27 @@
   <p:extLst>
     <p:ext uri="{521415D9-36F7-43E2-AB2F-B90AF26B5E84}">
       <p14:sectionLst xmlns:p14="http://schemas.microsoft.com/office/powerpoint/2010/main">
-        <p14:section name="Answer" id="{0f83076f-9998-5732-7fcc-db2a3f14f933}">
+        <p14:section name="Answer" id="{f2609ae3-2a9d-c07e-280a-b1a37f484f44}">
           <p14:sldIdLst>
             <p14:sldId id="256"/>
           </p14:sldIdLst>
         </p14:section>
-        <p14:section name="Method" id="{109aa765-6492-f3df-6a4f-c079b2a145f7}">
+        <p14:section name="Method" id="{3b1a851e-9eca-1171-4ce8-270e7f523451}">
           <p14:sldIdLst>
             <p14:sldId id="257"/>
           </p14:sldIdLst>
         </p14:section>
-        <p14:section name="Accuracy" id="{0c11f431-455a-5b29-53a7-6b7e22d139d6}">
+        <p14:section name="Accuracy" id="{f2c02a79-558c-b07e-029e-0ba1f8b52ac2}">
           <p14:sldIdLst>
             <p14:sldId id="258"/>
           </p14:sldIdLst>
         </p14:section>
-        <p14:section name="Shocks" id="{1f1f149e-81df-7446-c431-48dcee8269fb}">
+        <p14:section name="Shocks" id="{3d4472a2-ff48-525d-9c9b-0b55969a4268}">
           <p14:sldIdLst>
             <p14:sldId id="259"/>
           </p14:sldIdLst>
         </p14:section>
-        <p14:section name="Dashboard" id="{11cf349d-a102-bfe2-5c1e-309e1e8a1a2b}">
+        <p14:section name="Dashboard" id="{9d064e50-f456-2a3d-bbaa-2e1a392e6b44}">
           <p14:sldIdLst>
             <p14:sldId id="260"/>
           </p14:sldIdLst>
@@ -206,7 +206,7 @@
               <a:solidFill>
                 <a:srgbClr val="0F1B2D"/>
               </a:solidFill>
-              <a:prstDash val="solid,solid,dash,dash,sysDot,sysDot"/>
+              <a:prstDash val="solid"/>
               <a:round/>
             </a:ln>
             <a:effectLst/>
@@ -422,15 +422,6 @@
                 <c:pt idx="23">
                   <c:v>3.7703939514524443</c:v>
                 </c:pt>
-                <c:pt idx="24">
-                  <c:v/>
-                </c:pt>
-                <c:pt idx="25">
-                  <c:v/>
-                </c:pt>
-                <c:pt idx="26">
-                  <c:v/>
-                </c:pt>
               </c:numCache>
             </c:numRef>
           </c:val>
@@ -458,7 +449,7 @@
               <a:solidFill>
                 <a:srgbClr val="2A78D6"/>
               </a:solidFill>
-              <a:prstDash val="solid,solid,dash,dash,sysDot,sysDot"/>
+              <a:prstDash val="solid"/>
               <a:round/>
             </a:ln>
             <a:effectLst/>
@@ -602,75 +593,6 @@
               <c:numCache>
                 <c:formatCode>General</c:formatCode>
                 <c:ptCount val="27"/>
-                <c:pt idx="0">
-                  <c:v/>
-                </c:pt>
-                <c:pt idx="1">
-                  <c:v/>
-                </c:pt>
-                <c:pt idx="2">
-                  <c:v/>
-                </c:pt>
-                <c:pt idx="3">
-                  <c:v/>
-                </c:pt>
-                <c:pt idx="4">
-                  <c:v/>
-                </c:pt>
-                <c:pt idx="5">
-                  <c:v/>
-                </c:pt>
-                <c:pt idx="6">
-                  <c:v/>
-                </c:pt>
-                <c:pt idx="7">
-                  <c:v/>
-                </c:pt>
-                <c:pt idx="8">
-                  <c:v/>
-                </c:pt>
-                <c:pt idx="9">
-                  <c:v/>
-                </c:pt>
-                <c:pt idx="10">
-                  <c:v/>
-                </c:pt>
-                <c:pt idx="11">
-                  <c:v/>
-                </c:pt>
-                <c:pt idx="12">
-                  <c:v/>
-                </c:pt>
-                <c:pt idx="13">
-                  <c:v/>
-                </c:pt>
-                <c:pt idx="14">
-                  <c:v/>
-                </c:pt>
-                <c:pt idx="15">
-                  <c:v/>
-                </c:pt>
-                <c:pt idx="16">
-                  <c:v/>
-                </c:pt>
-                <c:pt idx="17">
-                  <c:v/>
-                </c:pt>
-                <c:pt idx="18">
-                  <c:v/>
-                </c:pt>
-                <c:pt idx="19">
-                  <c:v/>
-                </c:pt>
-                <c:pt idx="20">
-                  <c:v/>
-                </c:pt>
-                <c:pt idx="21">
-                  <c:v/>
-                </c:pt>
-                <c:pt idx="22">
-                  <c:v/>
-                </c:pt>
                 <c:pt idx="23">
                   <c:v>3.7703939514524443</c:v>
                 </c:pt>
@@ -704,13 +626,13 @@
           </c:tx>
           <c:spPr>
             <a:solidFill>
-              <a:srgbClr val="9DC0EC"/>
+              <a:srgbClr val="7FAEE6"/>
             </a:solidFill>
             <a:ln w="25400" cap="flat">
               <a:solidFill>
-                <a:srgbClr val="9DC0EC"/>
+                <a:srgbClr val="7FAEE6"/>
               </a:solidFill>
-              <a:prstDash val="solid,solid,dash,dash,sysDot,sysDot"/>
+              <a:prstDash val="solid"/>
               <a:round/>
             </a:ln>
             <a:effectLst/>
@@ -745,11 +667,11 @@
             <c:size val="6"/>
             <c:spPr>
               <a:solidFill>
-                <a:srgbClr val="9DC0EC"/>
+                <a:srgbClr val="7FAEE6"/>
               </a:solidFill>
               <a:ln w="9525" cap="flat">
                 <a:solidFill>
-                  <a:srgbClr val="9DC0EC"/>
+                  <a:srgbClr val="7FAEE6"/>
                 </a:solidFill>
                 <a:prstDash val="solid"/>
                 <a:round/>
@@ -854,75 +776,6 @@
               <c:numCache>
                 <c:formatCode>General</c:formatCode>
                 <c:ptCount val="27"/>
-                <c:pt idx="0">
-                  <c:v/>
-                </c:pt>
-                <c:pt idx="1">
-                  <c:v/>
-                </c:pt>
-                <c:pt idx="2">
-                  <c:v/>
-                </c:pt>
-                <c:pt idx="3">
-                  <c:v/>
-                </c:pt>
-                <c:pt idx="4">
-                  <c:v/>
-                </c:pt>
-                <c:pt idx="5">
-                  <c:v/>
-                </c:pt>
-                <c:pt idx="6">
-                  <c:v/>
-                </c:pt>
-                <c:pt idx="7">
-                  <c:v/>
-                </c:pt>
-                <c:pt idx="8">
-                  <c:v/>
-                </c:pt>
-                <c:pt idx="9">
-                  <c:v/>
-                </c:pt>
-                <c:pt idx="10">
-                  <c:v/>
-                </c:pt>
-                <c:pt idx="11">
-                  <c:v/>
-                </c:pt>
-                <c:pt idx="12">
-                  <c:v/>
-                </c:pt>
-                <c:pt idx="13">
-                  <c:v/>
-                </c:pt>
-                <c:pt idx="14">
-                  <c:v/>
-                </c:pt>
-                <c:pt idx="15">
-                  <c:v/>
-                </c:pt>
-                <c:pt idx="16">
-                  <c:v/>
-                </c:pt>
-                <c:pt idx="17">
-                  <c:v/>
-                </c:pt>
-                <c:pt idx="18">
-                  <c:v/>
-                </c:pt>
-                <c:pt idx="19">
-                  <c:v/>
-                </c:pt>
-                <c:pt idx="20">
-                  <c:v/>
-                </c:pt>
-                <c:pt idx="21">
-                  <c:v/>
-                </c:pt>
-                <c:pt idx="22">
-                  <c:v/>
-                </c:pt>
                 <c:pt idx="23">
                   <c:v>3.7703939514524443</c:v>
                 </c:pt>
@@ -956,13 +809,13 @@
           </c:tx>
           <c:spPr>
             <a:solidFill>
-              <a:srgbClr val="9DC0EC"/>
+              <a:srgbClr val="7FAEE6"/>
             </a:solidFill>
             <a:ln w="25400" cap="flat">
               <a:solidFill>
-                <a:srgbClr val="9DC0EC"/>
+                <a:srgbClr val="7FAEE6"/>
               </a:solidFill>
-              <a:prstDash val="solid,solid,dash,dash,sysDot,sysDot"/>
+              <a:prstDash val="solid"/>
               <a:round/>
             </a:ln>
             <a:effectLst/>
@@ -997,11 +850,11 @@
             <c:size val="6"/>
             <c:spPr>
               <a:solidFill>
-                <a:srgbClr val="9DC0EC"/>
+                <a:srgbClr val="7FAEE6"/>
               </a:solidFill>
               <a:ln w="9525" cap="flat">
                 <a:solidFill>
-                  <a:srgbClr val="9DC0EC"/>
+                  <a:srgbClr val="7FAEE6"/>
                 </a:solidFill>
                 <a:prstDash val="solid"/>
                 <a:round/>
@@ -1106,75 +959,6 @@
               <c:numCache>
                 <c:formatCode>General</c:formatCode>
                 <c:ptCount val="27"/>
-                <c:pt idx="0">
-                  <c:v/>
-                </c:pt>
-                <c:pt idx="1">
-                  <c:v/>
-                </c:pt>
-                <c:pt idx="2">
-                  <c:v/>
-                </c:pt>
-                <c:pt idx="3">
-                  <c:v/>
-                </c:pt>
-                <c:pt idx="4">
-                  <c:v/>
-                </c:pt>
-                <c:pt idx="5">
-                  <c:v/>
-                </c:pt>
-                <c:pt idx="6">
-                  <c:v/>
-                </c:pt>
-                <c:pt idx="7">
-                  <c:v/>
-                </c:pt>
-                <c:pt idx="8">
-                  <c:v/>
-                </c:pt>
-                <c:pt idx="9">
-                  <c:v/>
-                </c:pt>
-                <c:pt idx="10">
-                  <c:v/>
-                </c:pt>
-                <c:pt idx="11">
-                  <c:v/>
-                </c:pt>
-                <c:pt idx="12">
-                  <c:v/>
-                </c:pt>
-                <c:pt idx="13">
-                  <c:v/>
-                </c:pt>
-                <c:pt idx="14">
-                  <c:v/>
-                </c:pt>
-                <c:pt idx="15">
-                  <c:v/>
-                </c:pt>
-                <c:pt idx="16">
-                  <c:v/>
-                </c:pt>
-                <c:pt idx="17">
-                  <c:v/>
-                </c:pt>
-                <c:pt idx="18">
-                  <c:v/>
-                </c:pt>
-                <c:pt idx="19">
-                  <c:v/>
-                </c:pt>
-                <c:pt idx="20">
-                  <c:v/>
-                </c:pt>
-                <c:pt idx="21">
-                  <c:v/>
-                </c:pt>
-                <c:pt idx="22">
-                  <c:v/>
-                </c:pt>
                 <c:pt idx="23">
                   <c:v>3.7703939514524443</c:v>
                 </c:pt>
@@ -1214,7 +998,7 @@
               <a:solidFill>
                 <a:srgbClr val="C9DCF4"/>
               </a:solidFill>
-              <a:prstDash val="solid,solid,dash,dash,sysDot,sysDot"/>
+              <a:prstDash val="solid"/>
               <a:round/>
             </a:ln>
             <a:effectLst/>
@@ -1358,75 +1142,6 @@
               <c:numCache>
                 <c:formatCode>General</c:formatCode>
                 <c:ptCount val="27"/>
-                <c:pt idx="0">
-                  <c:v/>
-                </c:pt>
-                <c:pt idx="1">
-                  <c:v/>
-                </c:pt>
-                <c:pt idx="2">
-                  <c:v/>
-                </c:pt>
-                <c:pt idx="3">
-                  <c:v/>
-                </c:pt>
-                <c:pt idx="4">
-                  <c:v/>
-                </c:pt>
-                <c:pt idx="5">
-                  <c:v/>
-                </c:pt>
-                <c:pt idx="6">
-                  <c:v/>
-                </c:pt>
-                <c:pt idx="7">
-                  <c:v/>
-                </c:pt>
-                <c:pt idx="8">
-                  <c:v/>
-                </c:pt>
-                <c:pt idx="9">
-                  <c:v/>
-                </c:pt>
-                <c:pt idx="10">
-                  <c:v/>
-                </c:pt>
-                <c:pt idx="11">
-                  <c:v/>
-                </c:pt>
-                <c:pt idx="12">
-                  <c:v/>
-                </c:pt>
-                <c:pt idx="13">
-                  <c:v/>
-                </c:pt>
-                <c:pt idx="14">
-                  <c:v/>
-                </c:pt>
-                <c:pt idx="15">
-                  <c:v/>
-                </c:pt>
-                <c:pt idx="16">
-                  <c:v/>
-                </c:pt>
-                <c:pt idx="17">
-                  <c:v/>
-                </c:pt>
-                <c:pt idx="18">
-                  <c:v/>
-                </c:pt>
-                <c:pt idx="19">
-                  <c:v/>
-                </c:pt>
-                <c:pt idx="20">
-                  <c:v/>
-                </c:pt>
-                <c:pt idx="21">
-                  <c:v/>
-                </c:pt>
-                <c:pt idx="22">
-                  <c:v/>
-                </c:pt>
                 <c:pt idx="23">
                   <c:v>3.7703939514524443</c:v>
                 </c:pt>
@@ -1466,7 +1181,7 @@
               <a:solidFill>
                 <a:srgbClr val="C9DCF4"/>
               </a:solidFill>
-              <a:prstDash val="solid,solid,dash,dash,sysDot,sysDot"/>
+              <a:prstDash val="solid"/>
               <a:round/>
             </a:ln>
             <a:effectLst/>
@@ -1610,75 +1325,6 @@
               <c:numCache>
                 <c:formatCode>General</c:formatCode>
                 <c:ptCount val="27"/>
-                <c:pt idx="0">
-                  <c:v/>
-                </c:pt>
-                <c:pt idx="1">
-                  <c:v/>
-                </c:pt>
-                <c:pt idx="2">
-                  <c:v/>
-                </c:pt>
-                <c:pt idx="3">
-                  <c:v/>
-                </c:pt>
-                <c:pt idx="4">
-                  <c:v/>
-                </c:pt>
-                <c:pt idx="5">
-                  <c:v/>
-                </c:pt>
-                <c:pt idx="6">
-                  <c:v/>
-                </c:pt>
-                <c:pt idx="7">
-                  <c:v/>
-                </c:pt>
-                <c:pt idx="8">
-                  <c:v/>
-                </c:pt>
-                <c:pt idx="9">
-                  <c:v/>
-                </c:pt>
-                <c:pt idx="10">
-                  <c:v/>
-                </c:pt>
-                <c:pt idx="11">
-                  <c:v/>
-                </c:pt>
-                <c:pt idx="12">
-                  <c:v/>
-                </c:pt>
-                <c:pt idx="13">
-                  <c:v/>
-                </c:pt>
-                <c:pt idx="14">
-                  <c:v/>
-                </c:pt>
-                <c:pt idx="15">
-                  <c:v/>
-                </c:pt>
-                <c:pt idx="16">
-                  <c:v/>
-                </c:pt>
-                <c:pt idx="17">
-                  <c:v/>
-                </c:pt>
-                <c:pt idx="18">
-                  <c:v/>
-                </c:pt>
-                <c:pt idx="19">
-                  <c:v/>
-                </c:pt>
-                <c:pt idx="20">
-                  <c:v/>
-                </c:pt>
-                <c:pt idx="21">
-                  <c:v/>
-                </c:pt>
-                <c:pt idx="22">
-                  <c:v/>
-                </c:pt>
                 <c:pt idx="23">
                   <c:v>3.7703939514524443</c:v>
                 </c:pt>
@@ -4585,10 +4231,43 @@
             <a:r>
               <a:rPr lang="en-US" sz="1200" dirty="0">
                 <a:solidFill>
-                  <a:srgbClr val="5B6B82"/>
-                </a:solidFill>
-              </a:rPr>
-              <a:t>   dashed: 68% band   dotted: 90% band</a:t>
+                  <a:schemeClr val="tx1"/>
+                </a:solidFill>
+              </a:rPr>
+              <a:t>   </a:t>
+            </a:r>
+            <a:pPr indent="0" marL="0">
+              <a:buNone/>
+            </a:pPr>
+            <a:r>
+              <a:rPr lang="en-US" sz="1200" b="1" dirty="0">
+                <a:solidFill>
+                  <a:srgbClr val="7FAEE6"/>
+                </a:solidFill>
+              </a:rPr>
+              <a:t>68% band</a:t>
+            </a:r>
+            <a:pPr indent="0" marL="0">
+              <a:buNone/>
+            </a:pPr>
+            <a:r>
+              <a:rPr lang="en-US" sz="1200" dirty="0">
+                <a:solidFill>
+                  <a:schemeClr val="tx1"/>
+                </a:solidFill>
+              </a:rPr>
+              <a:t>   </a:t>
+            </a:r>
+            <a:pPr indent="0" marL="0">
+              <a:buNone/>
+            </a:pPr>
+            <a:r>
+              <a:rPr lang="en-US" sz="1200" b="1" dirty="0">
+                <a:solidFill>
+                  <a:srgbClr val="A9C7EE"/>
+                </a:solidFill>
+              </a:rPr>
+              <a:t>90% band</a:t>
             </a:r>
             <a:endParaRPr lang="en-US" sz="1200" dirty="0"/>
           </a:p>

</xml_diff>

<commit_message>
Deck review applied: shaded fan, named models, 8 pass + 1 warning with V8 explained, raw vs Holm-adjusted p, backtest vs prospective test, tighter titles (D72)
Co-Authored-By: Claude Opus 5.5 <noreply@anthropic.com>
</commit_message>
<xml_diff>
--- a/deck/deck.pptx
+++ b/deck/deck.pptx
@@ -111,27 +111,27 @@
   <p:extLst>
     <p:ext uri="{521415D9-36F7-43E2-AB2F-B90AF26B5E84}">
       <p14:sectionLst xmlns:p14="http://schemas.microsoft.com/office/powerpoint/2010/main">
-        <p14:section name="Answer" id="{f2609ae3-2a9d-c07e-280a-b1a37f484f44}">
+        <p14:section name="Answer" id="{2546a710-8138-4943-0690-62af48822cc5}">
           <p14:sldIdLst>
             <p14:sldId id="256"/>
           </p14:sldIdLst>
         </p14:section>
-        <p14:section name="Method" id="{3b1a851e-9eca-1171-4ce8-270e7f523451}">
+        <p14:section name="Method" id="{1a33c276-25d6-7a57-c7ce-7526f8e53f4b}">
           <p14:sldIdLst>
             <p14:sldId id="257"/>
           </p14:sldIdLst>
         </p14:section>
-        <p14:section name="Accuracy" id="{f2c02a79-558c-b07e-029e-0ba1f8b52ac2}">
+        <p14:section name="Accuracy" id="{8710abb4-968d-baaa-16ec-48c1cf1cb4e1}">
           <p14:sldIdLst>
             <p14:sldId id="258"/>
           </p14:sldIdLst>
         </p14:section>
-        <p14:section name="Shocks" id="{3d4472a2-ff48-525d-9c9b-0b55969a4268}">
+        <p14:section name="Shocks" id="{a7596c83-4191-1c61-b00b-3cec8344c036}">
           <p14:sldIdLst>
             <p14:sldId id="259"/>
           </p14:sldIdLst>
         </p14:section>
-        <p14:section name="Dashboard" id="{9d064e50-f456-2a3d-bbaa-2e1a392e6b44}">
+        <p14:section name="Dashboard" id="{63827812-e1aa-87b7-e47a-976ef9599b8a}">
           <p14:sldIdLst>
             <p14:sldId id="260"/>
           </p14:sldIdLst>
@@ -182,7 +182,8 @@
     <c:autoTitleDeleted val="0"/>
     <c:plotArea>
       <c:layout/>
-      <c:lineChart>
+      <c:areaChart>
+        <c:grouping val="stacked"/>
         <c:varyColors val="0"/>
         <c:ser>
           <c:idx val="0"/>
@@ -193,6 +194,944 @@
               <c:strCache>
                 <c:ptCount val="1"/>
                 <c:pt idx="0">
+                  <c:v>base</c:v>
+                </c:pt>
+              </c:strCache>
+            </c:strRef>
+          </c:tx>
+          <c:spPr>
+            <a:solidFill>
+              <a:srgbClr val="FFFFFF"/>
+            </a:solidFill>
+            <a:effectLst/>
+          </c:spPr>
+          <c:invertIfNegative val="0"/>
+          <c:dLbls>
+            <c:numFmt formatCode="#,##0" sourceLinked="0"/>
+            <c:txPr>
+              <a:bodyPr/>
+              <a:lstStyle/>
+              <a:p>
+                <a:pPr>
+                  <a:defRPr b="0" i="0" strike="noStrike" sz="1200" u="none">
+                    <a:solidFill>
+                      <a:srgbClr val="000000"/>
+                    </a:solidFill>
+                    <a:latin typeface="+mn-lt"/>
+                  </a:defRPr>
+                </a:pPr>
+              </a:p>
+            </c:txPr>
+            <c:showLegendKey val="0"/>
+            <c:showVal val="0"/>
+            <c:showCatName val="0"/>
+            <c:showSerName val="0"/>
+            <c:showPercent val="0"/>
+            <c:showBubbleSize val="0"/>
+            <c:showLeaderLines val="0"/>
+          </c:dLbls>
+          <c:cat>
+            <c:multiLvlStrRef>
+              <c:f>Sheet1!$A$2:$A$28</c:f>
+              <c:multiLvlStrCache>
+                <c:ptCount val="27"/>
+                <c:lvl>
+                  <c:pt idx="0">
+                    <c:v>Oct 24</c:v>
+                  </c:pt>
+                  <c:pt idx="1">
+                    <c:v>Nov 24</c:v>
+                  </c:pt>
+                  <c:pt idx="2">
+                    <c:v>Dec 24</c:v>
+                  </c:pt>
+                  <c:pt idx="3">
+                    <c:v>Jan 25</c:v>
+                  </c:pt>
+                  <c:pt idx="4">
+                    <c:v>Feb 25</c:v>
+                  </c:pt>
+                  <c:pt idx="5">
+                    <c:v>Mar 25</c:v>
+                  </c:pt>
+                  <c:pt idx="6">
+                    <c:v>Apr 25</c:v>
+                  </c:pt>
+                  <c:pt idx="7">
+                    <c:v>May 25</c:v>
+                  </c:pt>
+                  <c:pt idx="8">
+                    <c:v>Jun 25</c:v>
+                  </c:pt>
+                  <c:pt idx="9">
+                    <c:v>Jul 25</c:v>
+                  </c:pt>
+                  <c:pt idx="10">
+                    <c:v>Aug 25</c:v>
+                  </c:pt>
+                  <c:pt idx="11">
+                    <c:v>Sep 25</c:v>
+                  </c:pt>
+                  <c:pt idx="12">
+                    <c:v>Oct 25</c:v>
+                  </c:pt>
+                  <c:pt idx="13">
+                    <c:v>Nov 25</c:v>
+                  </c:pt>
+                  <c:pt idx="14">
+                    <c:v>Dec 25</c:v>
+                  </c:pt>
+                  <c:pt idx="15">
+                    <c:v>Jan 26</c:v>
+                  </c:pt>
+                  <c:pt idx="16">
+                    <c:v>Feb 26</c:v>
+                  </c:pt>
+                  <c:pt idx="17">
+                    <c:v>Mar 26</c:v>
+                  </c:pt>
+                  <c:pt idx="18">
+                    <c:v>Apr 26</c:v>
+                  </c:pt>
+                  <c:pt idx="19">
+                    <c:v>May 26</c:v>
+                  </c:pt>
+                  <c:pt idx="20">
+                    <c:v>Jun 26</c:v>
+                  </c:pt>
+                  <c:pt idx="21">
+                    <c:v>Jul 26</c:v>
+                  </c:pt>
+                  <c:pt idx="22">
+                    <c:v>Aug 26</c:v>
+                  </c:pt>
+                  <c:pt idx="23">
+                    <c:v>Sep 26</c:v>
+                  </c:pt>
+                  <c:pt idx="24">
+                    <c:v>Oct 26</c:v>
+                  </c:pt>
+                  <c:pt idx="25">
+                    <c:v>Nov 26</c:v>
+                  </c:pt>
+                  <c:pt idx="26">
+                    <c:v>Dec 26</c:v>
+                  </c:pt>
+                </c:lvl>
+              </c:multiLvlStrCache>
+            </c:multiLvlStrRef>
+          </c:cat>
+          <c:val>
+            <c:numRef>
+              <c:f>Sheet1!$B$2:$B$28</c:f>
+              <c:numCache>
+                <c:formatCode>General</c:formatCode>
+                <c:ptCount val="27"/>
+                <c:pt idx="0">
+                  <c:v>2.0055825493642043</c:v>
+                </c:pt>
+                <c:pt idx="1">
+                  <c:v>2.2455556710676783</c:v>
+                </c:pt>
+                <c:pt idx="2">
+                  <c:v>2.4286455630513792</c:v>
+                </c:pt>
+                <c:pt idx="3">
+                  <c:v>2.5208333333333277</c:v>
+                </c:pt>
+                <c:pt idx="4">
+                  <c:v>2.3188405797101463</c:v>
+                </c:pt>
+                <c:pt idx="5">
+                  <c:v>2.17815678619131</c:v>
+                </c:pt>
+                <c:pt idx="6">
+                  <c:v>2.1656961896005855</c:v>
+                </c:pt>
+                <c:pt idx="7">
+                  <c:v>1.8960244648318136</c:v>
+                </c:pt>
+                <c:pt idx="8">
+                  <c:v>1.9835215135795004</c:v>
+                </c:pt>
+                <c:pt idx="9">
+                  <c:v>2.0347949944043098</c:v>
+                </c:pt>
+                <c:pt idx="10">
+                  <c:v>2.042267831741529</c:v>
+                </c:pt>
+                <c:pt idx="11">
+                  <c:v>2.2271941421743158</c:v>
+                </c:pt>
+                <c:pt idx="12">
+                  <c:v>2.0979020979020824</c:v>
+                </c:pt>
+                <c:pt idx="13">
+                  <c:v>2.135231316725994</c:v>
+                </c:pt>
+                <c:pt idx="14">
+                  <c:v>1.9657513425878959</c:v>
+                </c:pt>
+                <c:pt idx="15">
+                  <c:v>1.6764885185937661</c:v>
+                </c:pt>
+                <c:pt idx="16">
+                  <c:v>1.8919465803318491</c:v>
+                </c:pt>
+                <c:pt idx="17">
+                  <c:v>2.554047259929604</c:v>
+                </c:pt>
+                <c:pt idx="18">
+                  <c:v>3.029697030296963</c:v>
+                </c:pt>
+                <c:pt idx="19">
+                  <c:v>3.171268507402969</c:v>
+                </c:pt>
+                <c:pt idx="20">
+                  <c:v>2.752842609216022</c:v>
+                </c:pt>
+                <c:pt idx="21">
+                  <c:v>2.9414697377604826</c:v>
+                </c:pt>
+                <c:pt idx="22">
+                  <c:v>3.2460420193169304</c:v>
+                </c:pt>
+                <c:pt idx="23">
+                  <c:v>3.7703939514524443</c:v>
+                </c:pt>
+                <c:pt idx="24">
+                  <c:v>3.491592567361237</c:v>
+                </c:pt>
+                <c:pt idx="25">
+                  <c:v>3.093708168999547</c:v>
+                </c:pt>
+                <c:pt idx="26">
+                  <c:v>2.998638531993297</c:v>
+                </c:pt>
+              </c:numCache>
+            </c:numRef>
+          </c:val>
+        </c:ser>
+        <c:ser>
+          <c:idx val="1"/>
+          <c:order val="1"/>
+          <c:tx>
+            <c:strRef>
+              <c:f>Sheet1!$C$1</c:f>
+              <c:strCache>
+                <c:ptCount val="1"/>
+                <c:pt idx="0">
+                  <c:v>90% band</c:v>
+                </c:pt>
+              </c:strCache>
+            </c:strRef>
+          </c:tx>
+          <c:spPr>
+            <a:solidFill>
+              <a:srgbClr val="C9DCF4"/>
+            </a:solidFill>
+            <a:effectLst/>
+          </c:spPr>
+          <c:invertIfNegative val="0"/>
+          <c:dLbls>
+            <c:numFmt formatCode="#,##0" sourceLinked="0"/>
+            <c:txPr>
+              <a:bodyPr/>
+              <a:lstStyle/>
+              <a:p>
+                <a:pPr>
+                  <a:defRPr b="0" i="0" strike="noStrike" sz="1200" u="none">
+                    <a:solidFill>
+                      <a:srgbClr val="000000"/>
+                    </a:solidFill>
+                    <a:latin typeface="+mn-lt"/>
+                  </a:defRPr>
+                </a:pPr>
+              </a:p>
+            </c:txPr>
+            <c:showLegendKey val="0"/>
+            <c:showVal val="0"/>
+            <c:showCatName val="0"/>
+            <c:showSerName val="0"/>
+            <c:showPercent val="0"/>
+            <c:showBubbleSize val="0"/>
+            <c:showLeaderLines val="0"/>
+          </c:dLbls>
+          <c:cat>
+            <c:multiLvlStrRef>
+              <c:f>Sheet1!$A$2:$A$28</c:f>
+              <c:multiLvlStrCache>
+                <c:ptCount val="27"/>
+                <c:lvl>
+                  <c:pt idx="0">
+                    <c:v>Oct 24</c:v>
+                  </c:pt>
+                  <c:pt idx="1">
+                    <c:v>Nov 24</c:v>
+                  </c:pt>
+                  <c:pt idx="2">
+                    <c:v>Dec 24</c:v>
+                  </c:pt>
+                  <c:pt idx="3">
+                    <c:v>Jan 25</c:v>
+                  </c:pt>
+                  <c:pt idx="4">
+                    <c:v>Feb 25</c:v>
+                  </c:pt>
+                  <c:pt idx="5">
+                    <c:v>Mar 25</c:v>
+                  </c:pt>
+                  <c:pt idx="6">
+                    <c:v>Apr 25</c:v>
+                  </c:pt>
+                  <c:pt idx="7">
+                    <c:v>May 25</c:v>
+                  </c:pt>
+                  <c:pt idx="8">
+                    <c:v>Jun 25</c:v>
+                  </c:pt>
+                  <c:pt idx="9">
+                    <c:v>Jul 25</c:v>
+                  </c:pt>
+                  <c:pt idx="10">
+                    <c:v>Aug 25</c:v>
+                  </c:pt>
+                  <c:pt idx="11">
+                    <c:v>Sep 25</c:v>
+                  </c:pt>
+                  <c:pt idx="12">
+                    <c:v>Oct 25</c:v>
+                  </c:pt>
+                  <c:pt idx="13">
+                    <c:v>Nov 25</c:v>
+                  </c:pt>
+                  <c:pt idx="14">
+                    <c:v>Dec 25</c:v>
+                  </c:pt>
+                  <c:pt idx="15">
+                    <c:v>Jan 26</c:v>
+                  </c:pt>
+                  <c:pt idx="16">
+                    <c:v>Feb 26</c:v>
+                  </c:pt>
+                  <c:pt idx="17">
+                    <c:v>Mar 26</c:v>
+                  </c:pt>
+                  <c:pt idx="18">
+                    <c:v>Apr 26</c:v>
+                  </c:pt>
+                  <c:pt idx="19">
+                    <c:v>May 26</c:v>
+                  </c:pt>
+                  <c:pt idx="20">
+                    <c:v>Jun 26</c:v>
+                  </c:pt>
+                  <c:pt idx="21">
+                    <c:v>Jul 26</c:v>
+                  </c:pt>
+                  <c:pt idx="22">
+                    <c:v>Aug 26</c:v>
+                  </c:pt>
+                  <c:pt idx="23">
+                    <c:v>Sep 26</c:v>
+                  </c:pt>
+                  <c:pt idx="24">
+                    <c:v>Oct 26</c:v>
+                  </c:pt>
+                  <c:pt idx="25">
+                    <c:v>Nov 26</c:v>
+                  </c:pt>
+                  <c:pt idx="26">
+                    <c:v>Dec 26</c:v>
+                  </c:pt>
+                </c:lvl>
+              </c:multiLvlStrCache>
+            </c:multiLvlStrRef>
+          </c:cat>
+          <c:val>
+            <c:numRef>
+              <c:f>Sheet1!$C$2:$C$28</c:f>
+              <c:numCache>
+                <c:formatCode>General</c:formatCode>
+                <c:ptCount val="27"/>
+                <c:pt idx="0">
+                  <c:v>0</c:v>
+                </c:pt>
+                <c:pt idx="1">
+                  <c:v>0</c:v>
+                </c:pt>
+                <c:pt idx="2">
+                  <c:v>0</c:v>
+                </c:pt>
+                <c:pt idx="3">
+                  <c:v>0</c:v>
+                </c:pt>
+                <c:pt idx="4">
+                  <c:v>0</c:v>
+                </c:pt>
+                <c:pt idx="5">
+                  <c:v>0</c:v>
+                </c:pt>
+                <c:pt idx="6">
+                  <c:v>0</c:v>
+                </c:pt>
+                <c:pt idx="7">
+                  <c:v>0</c:v>
+                </c:pt>
+                <c:pt idx="8">
+                  <c:v>0</c:v>
+                </c:pt>
+                <c:pt idx="9">
+                  <c:v>0</c:v>
+                </c:pt>
+                <c:pt idx="10">
+                  <c:v>0</c:v>
+                </c:pt>
+                <c:pt idx="11">
+                  <c:v>0</c:v>
+                </c:pt>
+                <c:pt idx="12">
+                  <c:v>0</c:v>
+                </c:pt>
+                <c:pt idx="13">
+                  <c:v>0</c:v>
+                </c:pt>
+                <c:pt idx="14">
+                  <c:v>0</c:v>
+                </c:pt>
+                <c:pt idx="15">
+                  <c:v>0</c:v>
+                </c:pt>
+                <c:pt idx="16">
+                  <c:v>0</c:v>
+                </c:pt>
+                <c:pt idx="17">
+                  <c:v>0</c:v>
+                </c:pt>
+                <c:pt idx="18">
+                  <c:v>0</c:v>
+                </c:pt>
+                <c:pt idx="19">
+                  <c:v>0</c:v>
+                </c:pt>
+                <c:pt idx="20">
+                  <c:v>0</c:v>
+                </c:pt>
+                <c:pt idx="21">
+                  <c:v>0</c:v>
+                </c:pt>
+                <c:pt idx="22">
+                  <c:v>0</c:v>
+                </c:pt>
+                <c:pt idx="23">
+                  <c:v>0</c:v>
+                </c:pt>
+                <c:pt idx="24">
+                  <c:v>0.11991664076378328</c:v>
+                </c:pt>
+                <c:pt idx="25">
+                  <c:v>0.3381287395588206</c:v>
+                </c:pt>
+                <c:pt idx="26">
+                  <c:v>0.39984668775426346</c:v>
+                </c:pt>
+              </c:numCache>
+            </c:numRef>
+          </c:val>
+        </c:ser>
+        <c:ser>
+          <c:idx val="2"/>
+          <c:order val="2"/>
+          <c:tx>
+            <c:strRef>
+              <c:f>Sheet1!$D$1</c:f>
+              <c:strCache>
+                <c:ptCount val="1"/>
+                <c:pt idx="0">
+                  <c:v>68% band</c:v>
+                </c:pt>
+              </c:strCache>
+            </c:strRef>
+          </c:tx>
+          <c:spPr>
+            <a:solidFill>
+              <a:srgbClr val="8FB8EA"/>
+            </a:solidFill>
+            <a:effectLst/>
+          </c:spPr>
+          <c:invertIfNegative val="0"/>
+          <c:dLbls>
+            <c:numFmt formatCode="#,##0" sourceLinked="0"/>
+            <c:txPr>
+              <a:bodyPr/>
+              <a:lstStyle/>
+              <a:p>
+                <a:pPr>
+                  <a:defRPr b="0" i="0" strike="noStrike" sz="1200" u="none">
+                    <a:solidFill>
+                      <a:srgbClr val="000000"/>
+                    </a:solidFill>
+                    <a:latin typeface="+mn-lt"/>
+                  </a:defRPr>
+                </a:pPr>
+              </a:p>
+            </c:txPr>
+            <c:showLegendKey val="0"/>
+            <c:showVal val="0"/>
+            <c:showCatName val="0"/>
+            <c:showSerName val="0"/>
+            <c:showPercent val="0"/>
+            <c:showBubbleSize val="0"/>
+            <c:showLeaderLines val="0"/>
+          </c:dLbls>
+          <c:cat>
+            <c:multiLvlStrRef>
+              <c:f>Sheet1!$A$2:$A$28</c:f>
+              <c:multiLvlStrCache>
+                <c:ptCount val="27"/>
+                <c:lvl>
+                  <c:pt idx="0">
+                    <c:v>Oct 24</c:v>
+                  </c:pt>
+                  <c:pt idx="1">
+                    <c:v>Nov 24</c:v>
+                  </c:pt>
+                  <c:pt idx="2">
+                    <c:v>Dec 24</c:v>
+                  </c:pt>
+                  <c:pt idx="3">
+                    <c:v>Jan 25</c:v>
+                  </c:pt>
+                  <c:pt idx="4">
+                    <c:v>Feb 25</c:v>
+                  </c:pt>
+                  <c:pt idx="5">
+                    <c:v>Mar 25</c:v>
+                  </c:pt>
+                  <c:pt idx="6">
+                    <c:v>Apr 25</c:v>
+                  </c:pt>
+                  <c:pt idx="7">
+                    <c:v>May 25</c:v>
+                  </c:pt>
+                  <c:pt idx="8">
+                    <c:v>Jun 25</c:v>
+                  </c:pt>
+                  <c:pt idx="9">
+                    <c:v>Jul 25</c:v>
+                  </c:pt>
+                  <c:pt idx="10">
+                    <c:v>Aug 25</c:v>
+                  </c:pt>
+                  <c:pt idx="11">
+                    <c:v>Sep 25</c:v>
+                  </c:pt>
+                  <c:pt idx="12">
+                    <c:v>Oct 25</c:v>
+                  </c:pt>
+                  <c:pt idx="13">
+                    <c:v>Nov 25</c:v>
+                  </c:pt>
+                  <c:pt idx="14">
+                    <c:v>Dec 25</c:v>
+                  </c:pt>
+                  <c:pt idx="15">
+                    <c:v>Jan 26</c:v>
+                  </c:pt>
+                  <c:pt idx="16">
+                    <c:v>Feb 26</c:v>
+                  </c:pt>
+                  <c:pt idx="17">
+                    <c:v>Mar 26</c:v>
+                  </c:pt>
+                  <c:pt idx="18">
+                    <c:v>Apr 26</c:v>
+                  </c:pt>
+                  <c:pt idx="19">
+                    <c:v>May 26</c:v>
+                  </c:pt>
+                  <c:pt idx="20">
+                    <c:v>Jun 26</c:v>
+                  </c:pt>
+                  <c:pt idx="21">
+                    <c:v>Jul 26</c:v>
+                  </c:pt>
+                  <c:pt idx="22">
+                    <c:v>Aug 26</c:v>
+                  </c:pt>
+                  <c:pt idx="23">
+                    <c:v>Sep 26</c:v>
+                  </c:pt>
+                  <c:pt idx="24">
+                    <c:v>Oct 26</c:v>
+                  </c:pt>
+                  <c:pt idx="25">
+                    <c:v>Nov 26</c:v>
+                  </c:pt>
+                  <c:pt idx="26">
+                    <c:v>Dec 26</c:v>
+                  </c:pt>
+                </c:lvl>
+              </c:multiLvlStrCache>
+            </c:multiLvlStrRef>
+          </c:cat>
+          <c:val>
+            <c:numRef>
+              <c:f>Sheet1!$D$2:$D$28</c:f>
+              <c:numCache>
+                <c:formatCode>General</c:formatCode>
+                <c:ptCount val="27"/>
+                <c:pt idx="0">
+                  <c:v>0</c:v>
+                </c:pt>
+                <c:pt idx="1">
+                  <c:v>0</c:v>
+                </c:pt>
+                <c:pt idx="2">
+                  <c:v>0</c:v>
+                </c:pt>
+                <c:pt idx="3">
+                  <c:v>0</c:v>
+                </c:pt>
+                <c:pt idx="4">
+                  <c:v>0</c:v>
+                </c:pt>
+                <c:pt idx="5">
+                  <c:v>0</c:v>
+                </c:pt>
+                <c:pt idx="6">
+                  <c:v>0</c:v>
+                </c:pt>
+                <c:pt idx="7">
+                  <c:v>0</c:v>
+                </c:pt>
+                <c:pt idx="8">
+                  <c:v>0</c:v>
+                </c:pt>
+                <c:pt idx="9">
+                  <c:v>0</c:v>
+                </c:pt>
+                <c:pt idx="10">
+                  <c:v>0</c:v>
+                </c:pt>
+                <c:pt idx="11">
+                  <c:v>0</c:v>
+                </c:pt>
+                <c:pt idx="12">
+                  <c:v>0</c:v>
+                </c:pt>
+                <c:pt idx="13">
+                  <c:v>0</c:v>
+                </c:pt>
+                <c:pt idx="14">
+                  <c:v>0</c:v>
+                </c:pt>
+                <c:pt idx="15">
+                  <c:v>0</c:v>
+                </c:pt>
+                <c:pt idx="16">
+                  <c:v>0</c:v>
+                </c:pt>
+                <c:pt idx="17">
+                  <c:v>0</c:v>
+                </c:pt>
+                <c:pt idx="18">
+                  <c:v>0</c:v>
+                </c:pt>
+                <c:pt idx="19">
+                  <c:v>0</c:v>
+                </c:pt>
+                <c:pt idx="20">
+                  <c:v>0</c:v>
+                </c:pt>
+                <c:pt idx="21">
+                  <c:v>0</c:v>
+                </c:pt>
+                <c:pt idx="22">
+                  <c:v>0</c:v>
+                </c:pt>
+                <c:pt idx="23">
+                  <c:v>0</c:v>
+                </c:pt>
+                <c:pt idx="24">
+                  <c:v>0.3291310199191342</c:v>
+                </c:pt>
+                <c:pt idx="25">
+                  <c:v>0.556852618208695</c:v>
+                </c:pt>
+                <c:pt idx="26">
+                  <c:v>0.8327773611581479</c:v>
+                </c:pt>
+              </c:numCache>
+            </c:numRef>
+          </c:val>
+        </c:ser>
+        <c:ser>
+          <c:idx val="3"/>
+          <c:order val="3"/>
+          <c:tx>
+            <c:strRef>
+              <c:f>Sheet1!$E$1</c:f>
+              <c:strCache>
+                <c:ptCount val="1"/>
+                <c:pt idx="0">
+                  <c:v>90% band upper</c:v>
+                </c:pt>
+              </c:strCache>
+            </c:strRef>
+          </c:tx>
+          <c:spPr>
+            <a:solidFill>
+              <a:srgbClr val="C9DCF4"/>
+            </a:solidFill>
+            <a:effectLst/>
+          </c:spPr>
+          <c:invertIfNegative val="0"/>
+          <c:dLbls>
+            <c:numFmt formatCode="#,##0" sourceLinked="0"/>
+            <c:txPr>
+              <a:bodyPr/>
+              <a:lstStyle/>
+              <a:p>
+                <a:pPr>
+                  <a:defRPr b="0" i="0" strike="noStrike" sz="1200" u="none">
+                    <a:solidFill>
+                      <a:srgbClr val="000000"/>
+                    </a:solidFill>
+                    <a:latin typeface="+mn-lt"/>
+                  </a:defRPr>
+                </a:pPr>
+              </a:p>
+            </c:txPr>
+            <c:showLegendKey val="0"/>
+            <c:showVal val="0"/>
+            <c:showCatName val="0"/>
+            <c:showSerName val="0"/>
+            <c:showPercent val="0"/>
+            <c:showBubbleSize val="0"/>
+            <c:showLeaderLines val="0"/>
+          </c:dLbls>
+          <c:cat>
+            <c:multiLvlStrRef>
+              <c:f>Sheet1!$A$2:$A$28</c:f>
+              <c:multiLvlStrCache>
+                <c:ptCount val="27"/>
+                <c:lvl>
+                  <c:pt idx="0">
+                    <c:v>Oct 24</c:v>
+                  </c:pt>
+                  <c:pt idx="1">
+                    <c:v>Nov 24</c:v>
+                  </c:pt>
+                  <c:pt idx="2">
+                    <c:v>Dec 24</c:v>
+                  </c:pt>
+                  <c:pt idx="3">
+                    <c:v>Jan 25</c:v>
+                  </c:pt>
+                  <c:pt idx="4">
+                    <c:v>Feb 25</c:v>
+                  </c:pt>
+                  <c:pt idx="5">
+                    <c:v>Mar 25</c:v>
+                  </c:pt>
+                  <c:pt idx="6">
+                    <c:v>Apr 25</c:v>
+                  </c:pt>
+                  <c:pt idx="7">
+                    <c:v>May 25</c:v>
+                  </c:pt>
+                  <c:pt idx="8">
+                    <c:v>Jun 25</c:v>
+                  </c:pt>
+                  <c:pt idx="9">
+                    <c:v>Jul 25</c:v>
+                  </c:pt>
+                  <c:pt idx="10">
+                    <c:v>Aug 25</c:v>
+                  </c:pt>
+                  <c:pt idx="11">
+                    <c:v>Sep 25</c:v>
+                  </c:pt>
+                  <c:pt idx="12">
+                    <c:v>Oct 25</c:v>
+                  </c:pt>
+                  <c:pt idx="13">
+                    <c:v>Nov 25</c:v>
+                  </c:pt>
+                  <c:pt idx="14">
+                    <c:v>Dec 25</c:v>
+                  </c:pt>
+                  <c:pt idx="15">
+                    <c:v>Jan 26</c:v>
+                  </c:pt>
+                  <c:pt idx="16">
+                    <c:v>Feb 26</c:v>
+                  </c:pt>
+                  <c:pt idx="17">
+                    <c:v>Mar 26</c:v>
+                  </c:pt>
+                  <c:pt idx="18">
+                    <c:v>Apr 26</c:v>
+                  </c:pt>
+                  <c:pt idx="19">
+                    <c:v>May 26</c:v>
+                  </c:pt>
+                  <c:pt idx="20">
+                    <c:v>Jun 26</c:v>
+                  </c:pt>
+                  <c:pt idx="21">
+                    <c:v>Jul 26</c:v>
+                  </c:pt>
+                  <c:pt idx="22">
+                    <c:v>Aug 26</c:v>
+                  </c:pt>
+                  <c:pt idx="23">
+                    <c:v>Sep 26</c:v>
+                  </c:pt>
+                  <c:pt idx="24">
+                    <c:v>Oct 26</c:v>
+                  </c:pt>
+                  <c:pt idx="25">
+                    <c:v>Nov 26</c:v>
+                  </c:pt>
+                  <c:pt idx="26">
+                    <c:v>Dec 26</c:v>
+                  </c:pt>
+                </c:lvl>
+              </c:multiLvlStrCache>
+            </c:multiLvlStrRef>
+          </c:cat>
+          <c:val>
+            <c:numRef>
+              <c:f>Sheet1!$E$2:$E$28</c:f>
+              <c:numCache>
+                <c:formatCode>General</c:formatCode>
+                <c:ptCount val="27"/>
+                <c:pt idx="0">
+                  <c:v>0</c:v>
+                </c:pt>
+                <c:pt idx="1">
+                  <c:v>0</c:v>
+                </c:pt>
+                <c:pt idx="2">
+                  <c:v>0</c:v>
+                </c:pt>
+                <c:pt idx="3">
+                  <c:v>0</c:v>
+                </c:pt>
+                <c:pt idx="4">
+                  <c:v>0</c:v>
+                </c:pt>
+                <c:pt idx="5">
+                  <c:v>0</c:v>
+                </c:pt>
+                <c:pt idx="6">
+                  <c:v>0</c:v>
+                </c:pt>
+                <c:pt idx="7">
+                  <c:v>0</c:v>
+                </c:pt>
+                <c:pt idx="8">
+                  <c:v>0</c:v>
+                </c:pt>
+                <c:pt idx="9">
+                  <c:v>0</c:v>
+                </c:pt>
+                <c:pt idx="10">
+                  <c:v>0</c:v>
+                </c:pt>
+                <c:pt idx="11">
+                  <c:v>0</c:v>
+                </c:pt>
+                <c:pt idx="12">
+                  <c:v>0</c:v>
+                </c:pt>
+                <c:pt idx="13">
+                  <c:v>0</c:v>
+                </c:pt>
+                <c:pt idx="14">
+                  <c:v>0</c:v>
+                </c:pt>
+                <c:pt idx="15">
+                  <c:v>0</c:v>
+                </c:pt>
+                <c:pt idx="16">
+                  <c:v>0</c:v>
+                </c:pt>
+                <c:pt idx="17">
+                  <c:v>0</c:v>
+                </c:pt>
+                <c:pt idx="18">
+                  <c:v>0</c:v>
+                </c:pt>
+                <c:pt idx="19">
+                  <c:v>0</c:v>
+                </c:pt>
+                <c:pt idx="20">
+                  <c:v>0</c:v>
+                </c:pt>
+                <c:pt idx="21">
+                  <c:v>0</c:v>
+                </c:pt>
+                <c:pt idx="22">
+                  <c:v>0</c:v>
+                </c:pt>
+                <c:pt idx="23">
+                  <c:v>0</c:v>
+                </c:pt>
+                <c:pt idx="24">
+                  <c:v>0.2591541155889674</c:v>
+                </c:pt>
+                <c:pt idx="25">
+                  <c:v>0.5494988675439858</c:v>
+                </c:pt>
+                <c:pt idx="26">
+                  <c:v>0.843272340756215</c:v>
+                </c:pt>
+              </c:numCache>
+            </c:numRef>
+          </c:val>
+        </c:ser>
+        <c:dLbls>
+          <c:numFmt formatCode="#,##0" sourceLinked="0"/>
+          <c:txPr>
+            <a:bodyPr/>
+            <a:lstStyle/>
+            <a:p>
+              <a:pPr>
+                <a:defRPr b="0" i="0" strike="noStrike" sz="1200" u="none">
+                  <a:solidFill>
+                    <a:srgbClr val="000000"/>
+                  </a:solidFill>
+                  <a:latin typeface="+mn-lt"/>
+                </a:defRPr>
+              </a:pPr>
+            </a:p>
+          </c:txPr>
+          <c:showLegendKey val="0"/>
+          <c:showVal val="0"/>
+          <c:showCatName val="0"/>
+          <c:showSerName val="0"/>
+          <c:showPercent val="0"/>
+          <c:showBubbleSize val="0"/>
+          <c:showLeaderLines val="0"/>
+        </c:dLbls>
+        <c:axId val="2094734554"/>
+        <c:axId val="2094734552"/>
+        <c:axId val="2094734556"/>
+      </c:areaChart>
+      <c:lineChart>
+        <c:varyColors val="0"/>
+        <c:ser>
+          <c:idx val="4"/>
+          <c:order val="4"/>
+          <c:tx>
+            <c:strRef>
+              <c:f>Sheet1!$F$1</c:f>
+              <c:strCache>
+                <c:ptCount val="1"/>
+                <c:pt idx="0">
                   <c:v>Actual</c:v>
                 </c:pt>
               </c:strCache>
@@ -202,9 +1141,252 @@
             <a:solidFill>
               <a:srgbClr val="0F1B2D"/>
             </a:solidFill>
-            <a:ln w="25400" cap="flat">
+            <a:ln w="28575" cap="flat">
               <a:solidFill>
                 <a:srgbClr val="0F1B2D"/>
+              </a:solidFill>
+              <a:prstDash val="solid"/>
+              <a:round/>
+            </a:ln>
+            <a:effectLst/>
+          </c:spPr>
+          <c:invertIfNegative val="0"/>
+          <c:dLbls>
+            <c:numFmt formatCode="#,##0" sourceLinked="0"/>
+            <c:txPr>
+              <a:bodyPr/>
+              <a:lstStyle/>
+              <a:p>
+                <a:pPr>
+                  <a:defRPr b="0" i="0" strike="noStrike" sz="1200" u="none">
+                    <a:solidFill>
+                      <a:srgbClr val="000000"/>
+                    </a:solidFill>
+                    <a:latin typeface="+mn-lt"/>
+                  </a:defRPr>
+                </a:pPr>
+              </a:p>
+            </c:txPr>
+            <c:showLegendKey val="0"/>
+            <c:showVal val="0"/>
+            <c:showCatName val="0"/>
+            <c:showSerName val="0"/>
+            <c:showPercent val="0"/>
+            <c:showBubbleSize val="0"/>
+            <c:showLeaderLines val="0"/>
+          </c:dLbls>
+          <c:marker>
+            <c:symbol val="none"/>
+            <c:size val="6"/>
+            <c:spPr>
+              <a:solidFill>
+                <a:srgbClr val="2A78D6"/>
+              </a:solidFill>
+              <a:ln w="9525" cap="flat">
+                <a:solidFill>
+                  <a:srgbClr val="0F1B2D"/>
+                </a:solidFill>
+                <a:prstDash val="solid"/>
+                <a:round/>
+              </a:ln>
+              <a:effectLst/>
+            </c:spPr>
+          </c:marker>
+          <c:cat>
+            <c:multiLvlStrRef>
+              <c:f>Sheet1!$A$2:$A$28</c:f>
+              <c:multiLvlStrCache>
+                <c:ptCount val="27"/>
+                <c:lvl>
+                  <c:pt idx="0">
+                    <c:v>Oct 24</c:v>
+                  </c:pt>
+                  <c:pt idx="1">
+                    <c:v>Nov 24</c:v>
+                  </c:pt>
+                  <c:pt idx="2">
+                    <c:v>Dec 24</c:v>
+                  </c:pt>
+                  <c:pt idx="3">
+                    <c:v>Jan 25</c:v>
+                  </c:pt>
+                  <c:pt idx="4">
+                    <c:v>Feb 25</c:v>
+                  </c:pt>
+                  <c:pt idx="5">
+                    <c:v>Mar 25</c:v>
+                  </c:pt>
+                  <c:pt idx="6">
+                    <c:v>Apr 25</c:v>
+                  </c:pt>
+                  <c:pt idx="7">
+                    <c:v>May 25</c:v>
+                  </c:pt>
+                  <c:pt idx="8">
+                    <c:v>Jun 25</c:v>
+                  </c:pt>
+                  <c:pt idx="9">
+                    <c:v>Jul 25</c:v>
+                  </c:pt>
+                  <c:pt idx="10">
+                    <c:v>Aug 25</c:v>
+                  </c:pt>
+                  <c:pt idx="11">
+                    <c:v>Sep 25</c:v>
+                  </c:pt>
+                  <c:pt idx="12">
+                    <c:v>Oct 25</c:v>
+                  </c:pt>
+                  <c:pt idx="13">
+                    <c:v>Nov 25</c:v>
+                  </c:pt>
+                  <c:pt idx="14">
+                    <c:v>Dec 25</c:v>
+                  </c:pt>
+                  <c:pt idx="15">
+                    <c:v>Jan 26</c:v>
+                  </c:pt>
+                  <c:pt idx="16">
+                    <c:v>Feb 26</c:v>
+                  </c:pt>
+                  <c:pt idx="17">
+                    <c:v>Mar 26</c:v>
+                  </c:pt>
+                  <c:pt idx="18">
+                    <c:v>Apr 26</c:v>
+                  </c:pt>
+                  <c:pt idx="19">
+                    <c:v>May 26</c:v>
+                  </c:pt>
+                  <c:pt idx="20">
+                    <c:v>Jun 26</c:v>
+                  </c:pt>
+                  <c:pt idx="21">
+                    <c:v>Jul 26</c:v>
+                  </c:pt>
+                  <c:pt idx="22">
+                    <c:v>Aug 26</c:v>
+                  </c:pt>
+                  <c:pt idx="23">
+                    <c:v>Sep 26</c:v>
+                  </c:pt>
+                  <c:pt idx="24">
+                    <c:v>Oct 26</c:v>
+                  </c:pt>
+                  <c:pt idx="25">
+                    <c:v>Nov 26</c:v>
+                  </c:pt>
+                  <c:pt idx="26">
+                    <c:v>Dec 26</c:v>
+                  </c:pt>
+                </c:lvl>
+              </c:multiLvlStrCache>
+            </c:multiLvlStrRef>
+          </c:cat>
+          <c:val>
+            <c:numRef>
+              <c:f>Sheet1!$F$2:$F$28</c:f>
+              <c:numCache>
+                <c:formatCode>General</c:formatCode>
+                <c:ptCount val="27"/>
+                <c:pt idx="0">
+                  <c:v>2.0055825493642043</c:v>
+                </c:pt>
+                <c:pt idx="1">
+                  <c:v>2.2455556710676783</c:v>
+                </c:pt>
+                <c:pt idx="2">
+                  <c:v>2.4286455630513792</c:v>
+                </c:pt>
+                <c:pt idx="3">
+                  <c:v>2.5208333333333277</c:v>
+                </c:pt>
+                <c:pt idx="4">
+                  <c:v>2.3188405797101463</c:v>
+                </c:pt>
+                <c:pt idx="5">
+                  <c:v>2.17815678619131</c:v>
+                </c:pt>
+                <c:pt idx="6">
+                  <c:v>2.1656961896005855</c:v>
+                </c:pt>
+                <c:pt idx="7">
+                  <c:v>1.8960244648318136</c:v>
+                </c:pt>
+                <c:pt idx="8">
+                  <c:v>1.9835215135795004</c:v>
+                </c:pt>
+                <c:pt idx="9">
+                  <c:v>2.0347949944043098</c:v>
+                </c:pt>
+                <c:pt idx="10">
+                  <c:v>2.042267831741529</c:v>
+                </c:pt>
+                <c:pt idx="11">
+                  <c:v>2.2271941421743158</c:v>
+                </c:pt>
+                <c:pt idx="12">
+                  <c:v>2.0979020979020824</c:v>
+                </c:pt>
+                <c:pt idx="13">
+                  <c:v>2.135231316725994</c:v>
+                </c:pt>
+                <c:pt idx="14">
+                  <c:v>1.9657513425878959</c:v>
+                </c:pt>
+                <c:pt idx="15">
+                  <c:v>1.6764885185937661</c:v>
+                </c:pt>
+                <c:pt idx="16">
+                  <c:v>1.8919465803318491</c:v>
+                </c:pt>
+                <c:pt idx="17">
+                  <c:v>2.554047259929604</c:v>
+                </c:pt>
+                <c:pt idx="18">
+                  <c:v>3.029697030296963</c:v>
+                </c:pt>
+                <c:pt idx="19">
+                  <c:v>3.171268507402969</c:v>
+                </c:pt>
+                <c:pt idx="20">
+                  <c:v>2.752842609216022</c:v>
+                </c:pt>
+                <c:pt idx="21">
+                  <c:v>2.9414697377604826</c:v>
+                </c:pt>
+                <c:pt idx="22">
+                  <c:v>3.2460420193169304</c:v>
+                </c:pt>
+                <c:pt idx="23">
+                  <c:v>3.7703939514524443</c:v>
+                </c:pt>
+              </c:numCache>
+            </c:numRef>
+          </c:val>
+          <c:smooth val="0"/>
+        </c:ser>
+        <c:ser>
+          <c:idx val="5"/>
+          <c:order val="5"/>
+          <c:tx>
+            <c:strRef>
+              <c:f>Sheet1!$G$1</c:f>
+              <c:strCache>
+                <c:ptCount val="1"/>
+                <c:pt idx="0">
+                  <c:v>Forecast</c:v>
+                </c:pt>
+              </c:strCache>
+            </c:strRef>
+          </c:tx>
+          <c:spPr>
+            <a:solidFill>
+              <a:srgbClr val="2A78D6"/>
+            </a:solidFill>
+            <a:ln w="28575" cap="flat">
+              <a:solidFill>
+                <a:srgbClr val="2A78D6"/>
               </a:solidFill>
               <a:prstDash val="solid"/>
               <a:round/>
@@ -245,7 +1427,7 @@
               </a:solidFill>
               <a:ln w="9525" cap="flat">
                 <a:solidFill>
-                  <a:srgbClr val="0F1B2D"/>
+                  <a:srgbClr val="2A78D6"/>
                 </a:solidFill>
                 <a:prstDash val="solid"/>
                 <a:round/>
@@ -346,981 +1528,6 @@
           </c:cat>
           <c:val>
             <c:numRef>
-              <c:f>Sheet1!$B$2:$B$28</c:f>
-              <c:numCache>
-                <c:formatCode>General</c:formatCode>
-                <c:ptCount val="27"/>
-                <c:pt idx="0">
-                  <c:v>2.0055825493642043</c:v>
-                </c:pt>
-                <c:pt idx="1">
-                  <c:v>2.2455556710676783</c:v>
-                </c:pt>
-                <c:pt idx="2">
-                  <c:v>2.4286455630513792</c:v>
-                </c:pt>
-                <c:pt idx="3">
-                  <c:v>2.5208333333333277</c:v>
-                </c:pt>
-                <c:pt idx="4">
-                  <c:v>2.3188405797101463</c:v>
-                </c:pt>
-                <c:pt idx="5">
-                  <c:v>2.17815678619131</c:v>
-                </c:pt>
-                <c:pt idx="6">
-                  <c:v>2.1656961896005855</c:v>
-                </c:pt>
-                <c:pt idx="7">
-                  <c:v>1.8960244648318136</c:v>
-                </c:pt>
-                <c:pt idx="8">
-                  <c:v>1.9835215135795004</c:v>
-                </c:pt>
-                <c:pt idx="9">
-                  <c:v>2.0347949944043098</c:v>
-                </c:pt>
-                <c:pt idx="10">
-                  <c:v>2.042267831741529</c:v>
-                </c:pt>
-                <c:pt idx="11">
-                  <c:v>2.2271941421743158</c:v>
-                </c:pt>
-                <c:pt idx="12">
-                  <c:v>2.0979020979020824</c:v>
-                </c:pt>
-                <c:pt idx="13">
-                  <c:v>2.135231316725994</c:v>
-                </c:pt>
-                <c:pt idx="14">
-                  <c:v>1.9657513425878959</c:v>
-                </c:pt>
-                <c:pt idx="15">
-                  <c:v>1.6764885185937661</c:v>
-                </c:pt>
-                <c:pt idx="16">
-                  <c:v>1.8919465803318491</c:v>
-                </c:pt>
-                <c:pt idx="17">
-                  <c:v>2.554047259929604</c:v>
-                </c:pt>
-                <c:pt idx="18">
-                  <c:v>3.029697030296963</c:v>
-                </c:pt>
-                <c:pt idx="19">
-                  <c:v>3.171268507402969</c:v>
-                </c:pt>
-                <c:pt idx="20">
-                  <c:v>2.752842609216022</c:v>
-                </c:pt>
-                <c:pt idx="21">
-                  <c:v>2.9414697377604826</c:v>
-                </c:pt>
-                <c:pt idx="22">
-                  <c:v>3.2460420193169304</c:v>
-                </c:pt>
-                <c:pt idx="23">
-                  <c:v>3.7703939514524443</c:v>
-                </c:pt>
-              </c:numCache>
-            </c:numRef>
-          </c:val>
-          <c:smooth val="0"/>
-        </c:ser>
-        <c:ser>
-          <c:idx val="1"/>
-          <c:order val="1"/>
-          <c:tx>
-            <c:strRef>
-              <c:f>Sheet1!$C$1</c:f>
-              <c:strCache>
-                <c:ptCount val="1"/>
-                <c:pt idx="0">
-                  <c:v>Forecast</c:v>
-                </c:pt>
-              </c:strCache>
-            </c:strRef>
-          </c:tx>
-          <c:spPr>
-            <a:solidFill>
-              <a:srgbClr val="2A78D6"/>
-            </a:solidFill>
-            <a:ln w="25400" cap="flat">
-              <a:solidFill>
-                <a:srgbClr val="2A78D6"/>
-              </a:solidFill>
-              <a:prstDash val="solid"/>
-              <a:round/>
-            </a:ln>
-            <a:effectLst/>
-          </c:spPr>
-          <c:invertIfNegative val="0"/>
-          <c:dLbls>
-            <c:numFmt formatCode="#,##0" sourceLinked="0"/>
-            <c:txPr>
-              <a:bodyPr/>
-              <a:lstStyle/>
-              <a:p>
-                <a:pPr>
-                  <a:defRPr b="0" i="0" strike="noStrike" sz="1200" u="none">
-                    <a:solidFill>
-                      <a:srgbClr val="000000"/>
-                    </a:solidFill>
-                    <a:latin typeface="+mn-lt"/>
-                  </a:defRPr>
-                </a:pPr>
-              </a:p>
-            </c:txPr>
-            <c:showLegendKey val="0"/>
-            <c:showVal val="0"/>
-            <c:showCatName val="0"/>
-            <c:showSerName val="0"/>
-            <c:showPercent val="0"/>
-            <c:showBubbleSize val="0"/>
-            <c:showLeaderLines val="0"/>
-          </c:dLbls>
-          <c:marker>
-            <c:symbol val="none"/>
-            <c:size val="6"/>
-            <c:spPr>
-              <a:solidFill>
-                <a:srgbClr val="2A78D6"/>
-              </a:solidFill>
-              <a:ln w="9525" cap="flat">
-                <a:solidFill>
-                  <a:srgbClr val="2A78D6"/>
-                </a:solidFill>
-                <a:prstDash val="solid"/>
-                <a:round/>
-              </a:ln>
-              <a:effectLst/>
-            </c:spPr>
-          </c:marker>
-          <c:cat>
-            <c:multiLvlStrRef>
-              <c:f>Sheet1!$A$2:$A$28</c:f>
-              <c:multiLvlStrCache>
-                <c:ptCount val="27"/>
-                <c:lvl>
-                  <c:pt idx="0">
-                    <c:v>Oct 24</c:v>
-                  </c:pt>
-                  <c:pt idx="1">
-                    <c:v>Nov 24</c:v>
-                  </c:pt>
-                  <c:pt idx="2">
-                    <c:v>Dec 24</c:v>
-                  </c:pt>
-                  <c:pt idx="3">
-                    <c:v>Jan 25</c:v>
-                  </c:pt>
-                  <c:pt idx="4">
-                    <c:v>Feb 25</c:v>
-                  </c:pt>
-                  <c:pt idx="5">
-                    <c:v>Mar 25</c:v>
-                  </c:pt>
-                  <c:pt idx="6">
-                    <c:v>Apr 25</c:v>
-                  </c:pt>
-                  <c:pt idx="7">
-                    <c:v>May 25</c:v>
-                  </c:pt>
-                  <c:pt idx="8">
-                    <c:v>Jun 25</c:v>
-                  </c:pt>
-                  <c:pt idx="9">
-                    <c:v>Jul 25</c:v>
-                  </c:pt>
-                  <c:pt idx="10">
-                    <c:v>Aug 25</c:v>
-                  </c:pt>
-                  <c:pt idx="11">
-                    <c:v>Sep 25</c:v>
-                  </c:pt>
-                  <c:pt idx="12">
-                    <c:v>Oct 25</c:v>
-                  </c:pt>
-                  <c:pt idx="13">
-                    <c:v>Nov 25</c:v>
-                  </c:pt>
-                  <c:pt idx="14">
-                    <c:v>Dec 25</c:v>
-                  </c:pt>
-                  <c:pt idx="15">
-                    <c:v>Jan 26</c:v>
-                  </c:pt>
-                  <c:pt idx="16">
-                    <c:v>Feb 26</c:v>
-                  </c:pt>
-                  <c:pt idx="17">
-                    <c:v>Mar 26</c:v>
-                  </c:pt>
-                  <c:pt idx="18">
-                    <c:v>Apr 26</c:v>
-                  </c:pt>
-                  <c:pt idx="19">
-                    <c:v>May 26</c:v>
-                  </c:pt>
-                  <c:pt idx="20">
-                    <c:v>Jun 26</c:v>
-                  </c:pt>
-                  <c:pt idx="21">
-                    <c:v>Jul 26</c:v>
-                  </c:pt>
-                  <c:pt idx="22">
-                    <c:v>Aug 26</c:v>
-                  </c:pt>
-                  <c:pt idx="23">
-                    <c:v>Sep 26</c:v>
-                  </c:pt>
-                  <c:pt idx="24">
-                    <c:v>Oct 26</c:v>
-                  </c:pt>
-                  <c:pt idx="25">
-                    <c:v>Nov 26</c:v>
-                  </c:pt>
-                  <c:pt idx="26">
-                    <c:v>Dec 26</c:v>
-                  </c:pt>
-                </c:lvl>
-              </c:multiLvlStrCache>
-            </c:multiLvlStrRef>
-          </c:cat>
-          <c:val>
-            <c:numRef>
-              <c:f>Sheet1!$C$2:$C$28</c:f>
-              <c:numCache>
-                <c:formatCode>General</c:formatCode>
-                <c:ptCount val="27"/>
-                <c:pt idx="23">
-                  <c:v>3.7703939514524443</c:v>
-                </c:pt>
-                <c:pt idx="24">
-                  <c:v>3.778144269083472</c:v>
-                </c:pt>
-                <c:pt idx="25">
-                  <c:v>3.6895580856292742</c:v>
-                </c:pt>
-                <c:pt idx="26">
-                  <c:v>3.7735759028955096</c:v>
-                </c:pt>
-              </c:numCache>
-            </c:numRef>
-          </c:val>
-          <c:smooth val="0"/>
-        </c:ser>
-        <c:ser>
-          <c:idx val="2"/>
-          <c:order val="2"/>
-          <c:tx>
-            <c:strRef>
-              <c:f>Sheet1!$D$1</c:f>
-              <c:strCache>
-                <c:ptCount val="1"/>
-                <c:pt idx="0">
-                  <c:v>68% band</c:v>
-                </c:pt>
-              </c:strCache>
-            </c:strRef>
-          </c:tx>
-          <c:spPr>
-            <a:solidFill>
-              <a:srgbClr val="7FAEE6"/>
-            </a:solidFill>
-            <a:ln w="25400" cap="flat">
-              <a:solidFill>
-                <a:srgbClr val="7FAEE6"/>
-              </a:solidFill>
-              <a:prstDash val="solid"/>
-              <a:round/>
-            </a:ln>
-            <a:effectLst/>
-          </c:spPr>
-          <c:invertIfNegative val="0"/>
-          <c:dLbls>
-            <c:numFmt formatCode="#,##0" sourceLinked="0"/>
-            <c:txPr>
-              <a:bodyPr/>
-              <a:lstStyle/>
-              <a:p>
-                <a:pPr>
-                  <a:defRPr b="0" i="0" strike="noStrike" sz="1200" u="none">
-                    <a:solidFill>
-                      <a:srgbClr val="000000"/>
-                    </a:solidFill>
-                    <a:latin typeface="+mn-lt"/>
-                  </a:defRPr>
-                </a:pPr>
-              </a:p>
-            </c:txPr>
-            <c:showLegendKey val="0"/>
-            <c:showVal val="0"/>
-            <c:showCatName val="0"/>
-            <c:showSerName val="0"/>
-            <c:showPercent val="0"/>
-            <c:showBubbleSize val="0"/>
-            <c:showLeaderLines val="0"/>
-          </c:dLbls>
-          <c:marker>
-            <c:symbol val="none"/>
-            <c:size val="6"/>
-            <c:spPr>
-              <a:solidFill>
-                <a:srgbClr val="7FAEE6"/>
-              </a:solidFill>
-              <a:ln w="9525" cap="flat">
-                <a:solidFill>
-                  <a:srgbClr val="7FAEE6"/>
-                </a:solidFill>
-                <a:prstDash val="solid"/>
-                <a:round/>
-              </a:ln>
-              <a:effectLst/>
-            </c:spPr>
-          </c:marker>
-          <c:cat>
-            <c:multiLvlStrRef>
-              <c:f>Sheet1!$A$2:$A$28</c:f>
-              <c:multiLvlStrCache>
-                <c:ptCount val="27"/>
-                <c:lvl>
-                  <c:pt idx="0">
-                    <c:v>Oct 24</c:v>
-                  </c:pt>
-                  <c:pt idx="1">
-                    <c:v>Nov 24</c:v>
-                  </c:pt>
-                  <c:pt idx="2">
-                    <c:v>Dec 24</c:v>
-                  </c:pt>
-                  <c:pt idx="3">
-                    <c:v>Jan 25</c:v>
-                  </c:pt>
-                  <c:pt idx="4">
-                    <c:v>Feb 25</c:v>
-                  </c:pt>
-                  <c:pt idx="5">
-                    <c:v>Mar 25</c:v>
-                  </c:pt>
-                  <c:pt idx="6">
-                    <c:v>Apr 25</c:v>
-                  </c:pt>
-                  <c:pt idx="7">
-                    <c:v>May 25</c:v>
-                  </c:pt>
-                  <c:pt idx="8">
-                    <c:v>Jun 25</c:v>
-                  </c:pt>
-                  <c:pt idx="9">
-                    <c:v>Jul 25</c:v>
-                  </c:pt>
-                  <c:pt idx="10">
-                    <c:v>Aug 25</c:v>
-                  </c:pt>
-                  <c:pt idx="11">
-                    <c:v>Sep 25</c:v>
-                  </c:pt>
-                  <c:pt idx="12">
-                    <c:v>Oct 25</c:v>
-                  </c:pt>
-                  <c:pt idx="13">
-                    <c:v>Nov 25</c:v>
-                  </c:pt>
-                  <c:pt idx="14">
-                    <c:v>Dec 25</c:v>
-                  </c:pt>
-                  <c:pt idx="15">
-                    <c:v>Jan 26</c:v>
-                  </c:pt>
-                  <c:pt idx="16">
-                    <c:v>Feb 26</c:v>
-                  </c:pt>
-                  <c:pt idx="17">
-                    <c:v>Mar 26</c:v>
-                  </c:pt>
-                  <c:pt idx="18">
-                    <c:v>Apr 26</c:v>
-                  </c:pt>
-                  <c:pt idx="19">
-                    <c:v>May 26</c:v>
-                  </c:pt>
-                  <c:pt idx="20">
-                    <c:v>Jun 26</c:v>
-                  </c:pt>
-                  <c:pt idx="21">
-                    <c:v>Jul 26</c:v>
-                  </c:pt>
-                  <c:pt idx="22">
-                    <c:v>Aug 26</c:v>
-                  </c:pt>
-                  <c:pt idx="23">
-                    <c:v>Sep 26</c:v>
-                  </c:pt>
-                  <c:pt idx="24">
-                    <c:v>Oct 26</c:v>
-                  </c:pt>
-                  <c:pt idx="25">
-                    <c:v>Nov 26</c:v>
-                  </c:pt>
-                  <c:pt idx="26">
-                    <c:v>Dec 26</c:v>
-                  </c:pt>
-                </c:lvl>
-              </c:multiLvlStrCache>
-            </c:multiLvlStrRef>
-          </c:cat>
-          <c:val>
-            <c:numRef>
-              <c:f>Sheet1!$D$2:$D$28</c:f>
-              <c:numCache>
-                <c:formatCode>General</c:formatCode>
-                <c:ptCount val="27"/>
-                <c:pt idx="23">
-                  <c:v>3.7703939514524443</c:v>
-                </c:pt>
-                <c:pt idx="24">
-                  <c:v>3.9406402280441544</c:v>
-                </c:pt>
-                <c:pt idx="25">
-                  <c:v>3.988689526767063</c:v>
-                </c:pt>
-                <c:pt idx="26">
-                  <c:v>4.2312625809057085</c:v>
-                </c:pt>
-              </c:numCache>
-            </c:numRef>
-          </c:val>
-          <c:smooth val="0"/>
-        </c:ser>
-        <c:ser>
-          <c:idx val="3"/>
-          <c:order val="3"/>
-          <c:tx>
-            <c:strRef>
-              <c:f>Sheet1!$E$1</c:f>
-              <c:strCache>
-                <c:ptCount val="1"/>
-                <c:pt idx="0">
-                  <c:v>68% band low</c:v>
-                </c:pt>
-              </c:strCache>
-            </c:strRef>
-          </c:tx>
-          <c:spPr>
-            <a:solidFill>
-              <a:srgbClr val="7FAEE6"/>
-            </a:solidFill>
-            <a:ln w="25400" cap="flat">
-              <a:solidFill>
-                <a:srgbClr val="7FAEE6"/>
-              </a:solidFill>
-              <a:prstDash val="solid"/>
-              <a:round/>
-            </a:ln>
-            <a:effectLst/>
-          </c:spPr>
-          <c:invertIfNegative val="0"/>
-          <c:dLbls>
-            <c:numFmt formatCode="#,##0" sourceLinked="0"/>
-            <c:txPr>
-              <a:bodyPr/>
-              <a:lstStyle/>
-              <a:p>
-                <a:pPr>
-                  <a:defRPr b="0" i="0" strike="noStrike" sz="1200" u="none">
-                    <a:solidFill>
-                      <a:srgbClr val="000000"/>
-                    </a:solidFill>
-                    <a:latin typeface="+mn-lt"/>
-                  </a:defRPr>
-                </a:pPr>
-              </a:p>
-            </c:txPr>
-            <c:showLegendKey val="0"/>
-            <c:showVal val="0"/>
-            <c:showCatName val="0"/>
-            <c:showSerName val="0"/>
-            <c:showPercent val="0"/>
-            <c:showBubbleSize val="0"/>
-            <c:showLeaderLines val="0"/>
-          </c:dLbls>
-          <c:marker>
-            <c:symbol val="none"/>
-            <c:size val="6"/>
-            <c:spPr>
-              <a:solidFill>
-                <a:srgbClr val="7FAEE6"/>
-              </a:solidFill>
-              <a:ln w="9525" cap="flat">
-                <a:solidFill>
-                  <a:srgbClr val="7FAEE6"/>
-                </a:solidFill>
-                <a:prstDash val="solid"/>
-                <a:round/>
-              </a:ln>
-              <a:effectLst/>
-            </c:spPr>
-          </c:marker>
-          <c:cat>
-            <c:multiLvlStrRef>
-              <c:f>Sheet1!$A$2:$A$28</c:f>
-              <c:multiLvlStrCache>
-                <c:ptCount val="27"/>
-                <c:lvl>
-                  <c:pt idx="0">
-                    <c:v>Oct 24</c:v>
-                  </c:pt>
-                  <c:pt idx="1">
-                    <c:v>Nov 24</c:v>
-                  </c:pt>
-                  <c:pt idx="2">
-                    <c:v>Dec 24</c:v>
-                  </c:pt>
-                  <c:pt idx="3">
-                    <c:v>Jan 25</c:v>
-                  </c:pt>
-                  <c:pt idx="4">
-                    <c:v>Feb 25</c:v>
-                  </c:pt>
-                  <c:pt idx="5">
-                    <c:v>Mar 25</c:v>
-                  </c:pt>
-                  <c:pt idx="6">
-                    <c:v>Apr 25</c:v>
-                  </c:pt>
-                  <c:pt idx="7">
-                    <c:v>May 25</c:v>
-                  </c:pt>
-                  <c:pt idx="8">
-                    <c:v>Jun 25</c:v>
-                  </c:pt>
-                  <c:pt idx="9">
-                    <c:v>Jul 25</c:v>
-                  </c:pt>
-                  <c:pt idx="10">
-                    <c:v>Aug 25</c:v>
-                  </c:pt>
-                  <c:pt idx="11">
-                    <c:v>Sep 25</c:v>
-                  </c:pt>
-                  <c:pt idx="12">
-                    <c:v>Oct 25</c:v>
-                  </c:pt>
-                  <c:pt idx="13">
-                    <c:v>Nov 25</c:v>
-                  </c:pt>
-                  <c:pt idx="14">
-                    <c:v>Dec 25</c:v>
-                  </c:pt>
-                  <c:pt idx="15">
-                    <c:v>Jan 26</c:v>
-                  </c:pt>
-                  <c:pt idx="16">
-                    <c:v>Feb 26</c:v>
-                  </c:pt>
-                  <c:pt idx="17">
-                    <c:v>Mar 26</c:v>
-                  </c:pt>
-                  <c:pt idx="18">
-                    <c:v>Apr 26</c:v>
-                  </c:pt>
-                  <c:pt idx="19">
-                    <c:v>May 26</c:v>
-                  </c:pt>
-                  <c:pt idx="20">
-                    <c:v>Jun 26</c:v>
-                  </c:pt>
-                  <c:pt idx="21">
-                    <c:v>Jul 26</c:v>
-                  </c:pt>
-                  <c:pt idx="22">
-                    <c:v>Aug 26</c:v>
-                  </c:pt>
-                  <c:pt idx="23">
-                    <c:v>Sep 26</c:v>
-                  </c:pt>
-                  <c:pt idx="24">
-                    <c:v>Oct 26</c:v>
-                  </c:pt>
-                  <c:pt idx="25">
-                    <c:v>Nov 26</c:v>
-                  </c:pt>
-                  <c:pt idx="26">
-                    <c:v>Dec 26</c:v>
-                  </c:pt>
-                </c:lvl>
-              </c:multiLvlStrCache>
-            </c:multiLvlStrRef>
-          </c:cat>
-          <c:val>
-            <c:numRef>
-              <c:f>Sheet1!$E$2:$E$28</c:f>
-              <c:numCache>
-                <c:formatCode>General</c:formatCode>
-                <c:ptCount val="27"/>
-                <c:pt idx="23">
-                  <c:v>3.7703939514524443</c:v>
-                </c:pt>
-                <c:pt idx="24">
-                  <c:v>3.61150920812502</c:v>
-                </c:pt>
-                <c:pt idx="25">
-                  <c:v>3.4318369085583678</c:v>
-                </c:pt>
-                <c:pt idx="26">
-                  <c:v>3.3984852197475606</c:v>
-                </c:pt>
-              </c:numCache>
-            </c:numRef>
-          </c:val>
-          <c:smooth val="0"/>
-        </c:ser>
-        <c:ser>
-          <c:idx val="4"/>
-          <c:order val="4"/>
-          <c:tx>
-            <c:strRef>
-              <c:f>Sheet1!$F$1</c:f>
-              <c:strCache>
-                <c:ptCount val="1"/>
-                <c:pt idx="0">
-                  <c:v>90% band</c:v>
-                </c:pt>
-              </c:strCache>
-            </c:strRef>
-          </c:tx>
-          <c:spPr>
-            <a:solidFill>
-              <a:srgbClr val="C9DCF4"/>
-            </a:solidFill>
-            <a:ln w="25400" cap="flat">
-              <a:solidFill>
-                <a:srgbClr val="C9DCF4"/>
-              </a:solidFill>
-              <a:prstDash val="solid"/>
-              <a:round/>
-            </a:ln>
-            <a:effectLst/>
-          </c:spPr>
-          <c:invertIfNegative val="0"/>
-          <c:dLbls>
-            <c:numFmt formatCode="#,##0" sourceLinked="0"/>
-            <c:txPr>
-              <a:bodyPr/>
-              <a:lstStyle/>
-              <a:p>
-                <a:pPr>
-                  <a:defRPr b="0" i="0" strike="noStrike" sz="1200" u="none">
-                    <a:solidFill>
-                      <a:srgbClr val="000000"/>
-                    </a:solidFill>
-                    <a:latin typeface="+mn-lt"/>
-                  </a:defRPr>
-                </a:pPr>
-              </a:p>
-            </c:txPr>
-            <c:showLegendKey val="0"/>
-            <c:showVal val="0"/>
-            <c:showCatName val="0"/>
-            <c:showSerName val="0"/>
-            <c:showPercent val="0"/>
-            <c:showBubbleSize val="0"/>
-            <c:showLeaderLines val="0"/>
-          </c:dLbls>
-          <c:marker>
-            <c:symbol val="none"/>
-            <c:size val="6"/>
-            <c:spPr>
-              <a:solidFill>
-                <a:srgbClr val="C9DCF4"/>
-              </a:solidFill>
-              <a:ln w="9525" cap="flat">
-                <a:solidFill>
-                  <a:srgbClr val="C9DCF4"/>
-                </a:solidFill>
-                <a:prstDash val="solid"/>
-                <a:round/>
-              </a:ln>
-              <a:effectLst/>
-            </c:spPr>
-          </c:marker>
-          <c:cat>
-            <c:multiLvlStrRef>
-              <c:f>Sheet1!$A$2:$A$28</c:f>
-              <c:multiLvlStrCache>
-                <c:ptCount val="27"/>
-                <c:lvl>
-                  <c:pt idx="0">
-                    <c:v>Oct 24</c:v>
-                  </c:pt>
-                  <c:pt idx="1">
-                    <c:v>Nov 24</c:v>
-                  </c:pt>
-                  <c:pt idx="2">
-                    <c:v>Dec 24</c:v>
-                  </c:pt>
-                  <c:pt idx="3">
-                    <c:v>Jan 25</c:v>
-                  </c:pt>
-                  <c:pt idx="4">
-                    <c:v>Feb 25</c:v>
-                  </c:pt>
-                  <c:pt idx="5">
-                    <c:v>Mar 25</c:v>
-                  </c:pt>
-                  <c:pt idx="6">
-                    <c:v>Apr 25</c:v>
-                  </c:pt>
-                  <c:pt idx="7">
-                    <c:v>May 25</c:v>
-                  </c:pt>
-                  <c:pt idx="8">
-                    <c:v>Jun 25</c:v>
-                  </c:pt>
-                  <c:pt idx="9">
-                    <c:v>Jul 25</c:v>
-                  </c:pt>
-                  <c:pt idx="10">
-                    <c:v>Aug 25</c:v>
-                  </c:pt>
-                  <c:pt idx="11">
-                    <c:v>Sep 25</c:v>
-                  </c:pt>
-                  <c:pt idx="12">
-                    <c:v>Oct 25</c:v>
-                  </c:pt>
-                  <c:pt idx="13">
-                    <c:v>Nov 25</c:v>
-                  </c:pt>
-                  <c:pt idx="14">
-                    <c:v>Dec 25</c:v>
-                  </c:pt>
-                  <c:pt idx="15">
-                    <c:v>Jan 26</c:v>
-                  </c:pt>
-                  <c:pt idx="16">
-                    <c:v>Feb 26</c:v>
-                  </c:pt>
-                  <c:pt idx="17">
-                    <c:v>Mar 26</c:v>
-                  </c:pt>
-                  <c:pt idx="18">
-                    <c:v>Apr 26</c:v>
-                  </c:pt>
-                  <c:pt idx="19">
-                    <c:v>May 26</c:v>
-                  </c:pt>
-                  <c:pt idx="20">
-                    <c:v>Jun 26</c:v>
-                  </c:pt>
-                  <c:pt idx="21">
-                    <c:v>Jul 26</c:v>
-                  </c:pt>
-                  <c:pt idx="22">
-                    <c:v>Aug 26</c:v>
-                  </c:pt>
-                  <c:pt idx="23">
-                    <c:v>Sep 26</c:v>
-                  </c:pt>
-                  <c:pt idx="24">
-                    <c:v>Oct 26</c:v>
-                  </c:pt>
-                  <c:pt idx="25">
-                    <c:v>Nov 26</c:v>
-                  </c:pt>
-                  <c:pt idx="26">
-                    <c:v>Dec 26</c:v>
-                  </c:pt>
-                </c:lvl>
-              </c:multiLvlStrCache>
-            </c:multiLvlStrRef>
-          </c:cat>
-          <c:val>
-            <c:numRef>
-              <c:f>Sheet1!$F$2:$F$28</c:f>
-              <c:numCache>
-                <c:formatCode>General</c:formatCode>
-                <c:ptCount val="27"/>
-                <c:pt idx="23">
-                  <c:v>3.7703939514524443</c:v>
-                </c:pt>
-                <c:pt idx="24">
-                  <c:v>4.199794343633122</c:v>
-                </c:pt>
-                <c:pt idx="25">
-                  <c:v>4.538188394311049</c:v>
-                </c:pt>
-                <c:pt idx="26">
-                  <c:v>5.0745349216619235</c:v>
-                </c:pt>
-              </c:numCache>
-            </c:numRef>
-          </c:val>
-          <c:smooth val="0"/>
-        </c:ser>
-        <c:ser>
-          <c:idx val="5"/>
-          <c:order val="5"/>
-          <c:tx>
-            <c:strRef>
-              <c:f>Sheet1!$G$1</c:f>
-              <c:strCache>
-                <c:ptCount val="1"/>
-                <c:pt idx="0">
-                  <c:v>90% band low</c:v>
-                </c:pt>
-              </c:strCache>
-            </c:strRef>
-          </c:tx>
-          <c:spPr>
-            <a:solidFill>
-              <a:srgbClr val="C9DCF4"/>
-            </a:solidFill>
-            <a:ln w="25400" cap="flat">
-              <a:solidFill>
-                <a:srgbClr val="C9DCF4"/>
-              </a:solidFill>
-              <a:prstDash val="solid"/>
-              <a:round/>
-            </a:ln>
-            <a:effectLst/>
-          </c:spPr>
-          <c:invertIfNegative val="0"/>
-          <c:dLbls>
-            <c:numFmt formatCode="#,##0" sourceLinked="0"/>
-            <c:txPr>
-              <a:bodyPr/>
-              <a:lstStyle/>
-              <a:p>
-                <a:pPr>
-                  <a:defRPr b="0" i="0" strike="noStrike" sz="1200" u="none">
-                    <a:solidFill>
-                      <a:srgbClr val="000000"/>
-                    </a:solidFill>
-                    <a:latin typeface="+mn-lt"/>
-                  </a:defRPr>
-                </a:pPr>
-              </a:p>
-            </c:txPr>
-            <c:showLegendKey val="0"/>
-            <c:showVal val="0"/>
-            <c:showCatName val="0"/>
-            <c:showSerName val="0"/>
-            <c:showPercent val="0"/>
-            <c:showBubbleSize val="0"/>
-            <c:showLeaderLines val="0"/>
-          </c:dLbls>
-          <c:marker>
-            <c:symbol val="none"/>
-            <c:size val="6"/>
-            <c:spPr>
-              <a:solidFill>
-                <a:srgbClr val="C9DCF4"/>
-              </a:solidFill>
-              <a:ln w="9525" cap="flat">
-                <a:solidFill>
-                  <a:srgbClr val="C9DCF4"/>
-                </a:solidFill>
-                <a:prstDash val="solid"/>
-                <a:round/>
-              </a:ln>
-              <a:effectLst/>
-            </c:spPr>
-          </c:marker>
-          <c:cat>
-            <c:multiLvlStrRef>
-              <c:f>Sheet1!$A$2:$A$28</c:f>
-              <c:multiLvlStrCache>
-                <c:ptCount val="27"/>
-                <c:lvl>
-                  <c:pt idx="0">
-                    <c:v>Oct 24</c:v>
-                  </c:pt>
-                  <c:pt idx="1">
-                    <c:v>Nov 24</c:v>
-                  </c:pt>
-                  <c:pt idx="2">
-                    <c:v>Dec 24</c:v>
-                  </c:pt>
-                  <c:pt idx="3">
-                    <c:v>Jan 25</c:v>
-                  </c:pt>
-                  <c:pt idx="4">
-                    <c:v>Feb 25</c:v>
-                  </c:pt>
-                  <c:pt idx="5">
-                    <c:v>Mar 25</c:v>
-                  </c:pt>
-                  <c:pt idx="6">
-                    <c:v>Apr 25</c:v>
-                  </c:pt>
-                  <c:pt idx="7">
-                    <c:v>May 25</c:v>
-                  </c:pt>
-                  <c:pt idx="8">
-                    <c:v>Jun 25</c:v>
-                  </c:pt>
-                  <c:pt idx="9">
-                    <c:v>Jul 25</c:v>
-                  </c:pt>
-                  <c:pt idx="10">
-                    <c:v>Aug 25</c:v>
-                  </c:pt>
-                  <c:pt idx="11">
-                    <c:v>Sep 25</c:v>
-                  </c:pt>
-                  <c:pt idx="12">
-                    <c:v>Oct 25</c:v>
-                  </c:pt>
-                  <c:pt idx="13">
-                    <c:v>Nov 25</c:v>
-                  </c:pt>
-                  <c:pt idx="14">
-                    <c:v>Dec 25</c:v>
-                  </c:pt>
-                  <c:pt idx="15">
-                    <c:v>Jan 26</c:v>
-                  </c:pt>
-                  <c:pt idx="16">
-                    <c:v>Feb 26</c:v>
-                  </c:pt>
-                  <c:pt idx="17">
-                    <c:v>Mar 26</c:v>
-                  </c:pt>
-                  <c:pt idx="18">
-                    <c:v>Apr 26</c:v>
-                  </c:pt>
-                  <c:pt idx="19">
-                    <c:v>May 26</c:v>
-                  </c:pt>
-                  <c:pt idx="20">
-                    <c:v>Jun 26</c:v>
-                  </c:pt>
-                  <c:pt idx="21">
-                    <c:v>Jul 26</c:v>
-                  </c:pt>
-                  <c:pt idx="22">
-                    <c:v>Aug 26</c:v>
-                  </c:pt>
-                  <c:pt idx="23">
-                    <c:v>Sep 26</c:v>
-                  </c:pt>
-                  <c:pt idx="24">
-                    <c:v>Oct 26</c:v>
-                  </c:pt>
-                  <c:pt idx="25">
-                    <c:v>Nov 26</c:v>
-                  </c:pt>
-                  <c:pt idx="26">
-                    <c:v>Dec 26</c:v>
-                  </c:pt>
-                </c:lvl>
-              </c:multiLvlStrCache>
-            </c:multiLvlStrRef>
-          </c:cat>
-          <c:val>
-            <c:numRef>
               <c:f>Sheet1!$G$2:$G$28</c:f>
               <c:numCache>
                 <c:formatCode>General</c:formatCode>
@@ -1329,13 +1536,13 @@
                   <c:v>3.7703939514524443</c:v>
                 </c:pt>
                 <c:pt idx="24">
-                  <c:v>3.491592567361237</c:v>
+                  <c:v>3.778144269083472</c:v>
                 </c:pt>
                 <c:pt idx="25">
-                  <c:v>3.093708168999547</c:v>
+                  <c:v>3.6895580856292742</c:v>
                 </c:pt>
                 <c:pt idx="26">
-                  <c:v>2.998638531993297</c:v>
+                  <c:v>3.7735759028955096</c:v>
                 </c:pt>
               </c:numCache>
             </c:numRef>
@@ -1422,17 +1629,6 @@
         </c:scaling>
         <c:delete val="0"/>
         <c:axPos val="l"/>
-        <c:majorGridlines>
-          <c:spPr>
-            <a:ln w="6350" cap="flat">
-              <a:solidFill>
-                <a:srgbClr val="E3E8EF"/>
-              </a:solidFill>
-              <a:prstDash val="solid"/>
-              <a:round/>
-            </a:ln>
-          </c:spPr>
-        </c:majorGridlines>
         <c:numFmt formatCode="0.0" sourceLinked="0"/>
         <c:majorTickMark val="out"/>
         <c:minorTickMark val="none"/>
@@ -1463,7 +1659,7 @@
         </c:txPr>
         <c:crossAx val="2094734554"/>
         <c:crosses val="autoZero"/>
-        <c:crossBetween val="between"/>
+        <c:crossBetween val="midCat"/>
       </c:valAx>
       <c:spPr>
         <a:noFill/>
@@ -2691,6 +2887,7 @@
               <a:t>For validation and structured outputs. Nothing is downloaded by hand: the pipeline pulls Eurostat's HICP index, item and country weights and the official contributions through the API, and records the vintage of every pull.
 Before any model runs, 9 gates check the data; 8 pass and V8 is a documented warning, not a failure.
 The strongest check is the reconciliation: we rebuild Eurostat's headline from the six components with annual chain-linked Laspeyres weights and a December link. Over 309 months the largest gap is 0.030 pp, and the contributions match Eurostat's within 0.009 pp. If our arithmetic is right there, the forecast's contributions can be trusted.
+The forecast itself is bottom-up: each component's monthly price change is forecast with what won in the backtest (pump prices for fuels, a seasonal mean for electricity &amp; gas and unprocessed food, an AR(p) for processed food, and "no change in y/y" for goods and services), then chain-linked to the headline with the weights known at the forecast date.
 Every model rule was written and committed before results existed, and every output is schema-validated JSON. 217 automated tests cover the maths and the data contracts.</a:t>
             </a:r>
             <a:endParaRPr lang="en-US" dirty="0"/>
@@ -2779,10 +2976,10 @@
           <a:p>
             <a:r>
               <a:rPr lang="en-US" dirty="0"/>
-              <a:t>The benchmark that matters at short horizons is the random walk, "y/y stays where it is", which most inflation models fail to beat. Out of sample over 198 forecast origins, our three-month error is 0.63 pp against 0.80 pp, a ratio of 0.79. The Diebold-Mariano test (HLN correction, Newey-West) gives p = 0.016.
+              <a:t>The benchmark that matters at short horizons is the random walk, "y/y stays where it is", which most inflation models fail to beat. Out of sample over 198 forecast origins, our three-month error is 0.63 pp against 0.80 pp, a ratio of 0.79. The Diebold-Mariano test (HLN correction, Newey-West) gives a raw p of 0.016; Holm across round 4's 3 tests compares it with 0.0167, so the Holm-adjusted p is 0.049: significant at 5%, narrowly.
 The gain is the same before and after 2020, which makes it less likely to be a crisis accident.
 Be upfront about the limits: in 2020-23 only 35% of outcomes fell inside the 68% band and the model under-predicted by 0.37 pp on average. In June 2022 it said 6.8% and inflation was 8.6%.
-On model choice: there were 4 rounds, each with its rule fixed and committed first. The adopted variant passed narrowly (p 0.016 against a Holm threshold of 0.0167). The model is now frozen, and the hash-chained ledger is the clean out-of-sample test from here.</a:t>
+On model choice: there were 4 rounds, each with its rule fixed and committed first. The adopted variant passed narrowly (p 0.016 against a Holm threshold of 0.0167). The backtest is pseudo out-of-sample: it uses latest-vintage data, and the model was chosen on that same history, so it carries some selection optimism. The model was frozen on 21 Oct 2026; from there the hash-chained ledger is the clean prospective test.</a:t>
             </a:r>
             <a:endParaRPr lang="en-US" dirty="0"/>
           </a:p>
@@ -3114,7 +3311,7 @@
                   <a:schemeClr val="bg2"/>
                 </a:solidFill>
               </a:rPr>
-              <a:t>EuroPulse · Source: Eurostat HICP (prc_hicp_minr, prc_hicp_iw, prc_hicp_cw, prc_hicp_ctr), own calculations · data to Sep 2026 · run 2026-10-22 (b70cab4)</a:t>
+              <a:t>EuroPulse · Source: Eurostat HICP (prc_hicp_minr, prc_hicp_iw, prc_hicp_cw, prc_hicp_ctr), own calculations · data to Sep 2026 · run 2026-10-22 (b883938)</a:t>
             </a:r>
             <a:endParaRPr lang="en-US" sz="1000" dirty="0"/>
           </a:p>
@@ -3251,7 +3448,7 @@
                   <a:schemeClr val="accent3"/>
                 </a:solidFill>
               </a:rPr>
-              <a:t>EuroPulse · Source: Eurostat HICP (prc_hicp_minr, prc_hicp_iw, prc_hicp_cw, prc_hicp_ctr), own calculations · data to Sep 2026 · run 2026-10-22 (b70cab4)</a:t>
+              <a:t>EuroPulse · Source: Eurostat HICP (prc_hicp_minr, prc_hicp_iw, prc_hicp_cw, prc_hicp_ctr), own calculations · data to Sep 2026 · run 2026-10-22 (b883938)</a:t>
             </a:r>
             <a:endParaRPr lang="en-US" sz="1000" dirty="0"/>
           </a:p>
@@ -4242,7 +4439,7 @@
             <a:r>
               <a:rPr lang="en-US" sz="1200" b="1" dirty="0">
                 <a:solidFill>
-                  <a:srgbClr val="7FAEE6"/>
+                  <a:srgbClr val="6F9FDB"/>
                 </a:solidFill>
               </a:rPr>
               <a:t>68% band</a:t>
@@ -4264,10 +4461,21 @@
             <a:r>
               <a:rPr lang="en-US" sz="1200" b="1" dirty="0">
                 <a:solidFill>
-                  <a:srgbClr val="A9C7EE"/>
+                  <a:srgbClr val="9DB9DE"/>
                 </a:solidFill>
               </a:rPr>
               <a:t>90% band</a:t>
+            </a:r>
+            <a:pPr indent="0" marL="0">
+              <a:buNone/>
+            </a:pPr>
+            <a:r>
+              <a:rPr lang="en-US" sz="1200" dirty="0">
+                <a:solidFill>
+                  <a:srgbClr val="5B6B82"/>
+                </a:solidFill>
+              </a:rPr>
+              <a:t>   (from past forecast errors)</a:t>
             </a:r>
             <a:endParaRPr lang="en-US" sz="1200" dirty="0"/>
           </a:p>
@@ -4415,7 +4623,7 @@
                 <a:ea typeface="Cambria" pitchFamily="34" charset="-122"/>
                 <a:cs typeface="Cambria" pitchFamily="34" charset="-120"/>
               </a:rPr>
-              <a:t>Every number is checked before it is shown</a:t>
+              <a:t>Validated data and reproducible calculations</a:t>
             </a:r>
             <a:endParaRPr lang="en-US" sz="3400" dirty="0"/>
           </a:p>
@@ -4527,7 +4735,7 @@
         <p:spPr>
           <a:xfrm>
             <a:off x="1097280" y="2167128"/>
-            <a:ext cx="3063240" cy="566928"/>
+            <a:ext cx="3063240" cy="960120"/>
           </a:xfrm>
           <a:prstGeom prst="rect">
             <a:avLst/>
@@ -4660,7 +4868,7 @@
         <p:spPr>
           <a:xfrm>
             <a:off x="4892040" y="2167128"/>
-            <a:ext cx="3063240" cy="566928"/>
+            <a:ext cx="3063240" cy="960120"/>
           </a:xfrm>
           <a:prstGeom prst="rect">
             <a:avLst/>
@@ -4695,7 +4903,7 @@
         </p:nvSpPr>
         <p:spPr>
           <a:xfrm>
-            <a:off x="548640" y="3108960"/>
+            <a:off x="548640" y="3246120"/>
             <a:ext cx="420624" cy="420624"/>
           </a:xfrm>
           <a:prstGeom prst="ellipse">
@@ -4720,7 +4928,7 @@
         </p:nvSpPr>
         <p:spPr>
           <a:xfrm>
-            <a:off x="548640" y="3108960"/>
+            <a:off x="548640" y="3246120"/>
             <a:ext cx="420624" cy="420624"/>
           </a:xfrm>
           <a:prstGeom prst="rect">
@@ -4756,7 +4964,7 @@
         </p:nvSpPr>
         <p:spPr>
           <a:xfrm>
-            <a:off x="1097280" y="3090672"/>
+            <a:off x="1097280" y="3227832"/>
             <a:ext cx="3063240" cy="292608"/>
           </a:xfrm>
           <a:prstGeom prst="rect">
@@ -4792,8 +5000,8 @@
         </p:nvSpPr>
         <p:spPr>
           <a:xfrm>
-            <a:off x="1097280" y="3401568"/>
-            <a:ext cx="3063240" cy="566928"/>
+            <a:off x="1097280" y="3538728"/>
+            <a:ext cx="3063240" cy="960120"/>
           </a:xfrm>
           <a:prstGeom prst="rect">
             <a:avLst/>
@@ -4828,7 +5036,7 @@
         </p:nvSpPr>
         <p:spPr>
           <a:xfrm>
-            <a:off x="4343400" y="3108960"/>
+            <a:off x="4343400" y="3246120"/>
             <a:ext cx="420624" cy="420624"/>
           </a:xfrm>
           <a:prstGeom prst="ellipse">
@@ -4853,7 +5061,7 @@
         </p:nvSpPr>
         <p:spPr>
           <a:xfrm>
-            <a:off x="4343400" y="3108960"/>
+            <a:off x="4343400" y="3246120"/>
             <a:ext cx="420624" cy="420624"/>
           </a:xfrm>
           <a:prstGeom prst="rect">
@@ -4889,7 +5097,7 @@
         </p:nvSpPr>
         <p:spPr>
           <a:xfrm>
-            <a:off x="4892040" y="3090672"/>
+            <a:off x="4892040" y="3227832"/>
             <a:ext cx="3063240" cy="292608"/>
           </a:xfrm>
           <a:prstGeom prst="rect">
@@ -4925,8 +5133,8 @@
         </p:nvSpPr>
         <p:spPr>
           <a:xfrm>
-            <a:off x="4892040" y="3401568"/>
-            <a:ext cx="3063240" cy="566928"/>
+            <a:off x="4892040" y="3538728"/>
+            <a:ext cx="3063240" cy="960120"/>
           </a:xfrm>
           <a:prstGeom prst="rect">
             <a:avLst/>
@@ -4947,7 +5155,7 @@
                   <a:schemeClr val="accent3"/>
                 </a:solidFill>
               </a:rPr>
-              <a:t>Six components, each with its own model, aggregated with the weights known at the forecast date.</a:t>
+              <a:t>Monthly price change per component. Fuels: pump prices; electricity &amp; gas, unprocessed food: seasonal mean; processed food: AR(p); goods, services: 'no change in y/y'.</a:t>
             </a:r>
             <a:endParaRPr lang="en-US" sz="1300" dirty="0"/>
           </a:p>
@@ -4961,7 +5169,7 @@
         </p:nvSpPr>
         <p:spPr>
           <a:xfrm>
-            <a:off x="548640" y="4343400"/>
+            <a:off x="548640" y="4617720"/>
             <a:ext cx="420624" cy="420624"/>
           </a:xfrm>
           <a:prstGeom prst="ellipse">
@@ -4986,7 +5194,7 @@
         </p:nvSpPr>
         <p:spPr>
           <a:xfrm>
-            <a:off x="548640" y="4343400"/>
+            <a:off x="548640" y="4617720"/>
             <a:ext cx="420624" cy="420624"/>
           </a:xfrm>
           <a:prstGeom prst="rect">
@@ -5022,7 +5230,7 @@
         </p:nvSpPr>
         <p:spPr>
           <a:xfrm>
-            <a:off x="1097280" y="4325112"/>
+            <a:off x="1097280" y="4599432"/>
             <a:ext cx="3063240" cy="292608"/>
           </a:xfrm>
           <a:prstGeom prst="rect">
@@ -5058,8 +5266,8 @@
         </p:nvSpPr>
         <p:spPr>
           <a:xfrm>
-            <a:off x="1097280" y="4636008"/>
-            <a:ext cx="3063240" cy="566928"/>
+            <a:off x="1097280" y="4910328"/>
+            <a:ext cx="3063240" cy="960120"/>
           </a:xfrm>
           <a:prstGeom prst="rect">
             <a:avLst/>
@@ -5094,7 +5302,7 @@
         </p:nvSpPr>
         <p:spPr>
           <a:xfrm>
-            <a:off x="4343400" y="4343400"/>
+            <a:off x="4343400" y="4617720"/>
             <a:ext cx="420624" cy="420624"/>
           </a:xfrm>
           <a:prstGeom prst="ellipse">
@@ -5119,7 +5327,7 @@
         </p:nvSpPr>
         <p:spPr>
           <a:xfrm>
-            <a:off x="4343400" y="4343400"/>
+            <a:off x="4343400" y="4617720"/>
             <a:ext cx="420624" cy="420624"/>
           </a:xfrm>
           <a:prstGeom prst="rect">
@@ -5155,7 +5363,7 @@
         </p:nvSpPr>
         <p:spPr>
           <a:xfrm>
-            <a:off x="4892040" y="4325112"/>
+            <a:off x="4892040" y="4599432"/>
             <a:ext cx="3063240" cy="292608"/>
           </a:xfrm>
           <a:prstGeom prst="rect">
@@ -5191,8 +5399,8 @@
         </p:nvSpPr>
         <p:spPr>
           <a:xfrm>
-            <a:off x="4892040" y="4636008"/>
-            <a:ext cx="3063240" cy="566928"/>
+            <a:off x="4892040" y="4910328"/>
+            <a:ext cx="3063240" cy="960120"/>
           </a:xfrm>
           <a:prstGeom prst="rect">
             <a:avLst/>
@@ -5248,7 +5456,7 @@
       </p:sp>
       <p:sp>
         <p:nvSpPr>
-          <p:cNvPr id="29" name="stat data checks without a failure"/>
+          <p:cNvPr id="29" name="stat of 9 data checks; the warning (V8) flags 61 outlier observations, kept, not dropped"/>
           <p:cNvSpPr txBox="1"/>
           <p:nvPr/>
         </p:nvSpPr>
@@ -5271,7 +5479,7 @@
               <a:buNone/>
             </a:pPr>
             <a:r>
-              <a:rPr lang="en-US" sz="4000" b="1" dirty="0">
+              <a:rPr lang="en-US" sz="2600" b="1" dirty="0">
                 <a:solidFill>
                   <a:schemeClr val="accent1"/>
                 </a:solidFill>
@@ -5279,21 +5487,21 @@
                 <a:ea typeface="Cambria" pitchFamily="34" charset="-122"/>
                 <a:cs typeface="Cambria" pitchFamily="34" charset="-120"/>
               </a:rPr>
-              <a:t>9/9</a:t>
-            </a:r>
-            <a:endParaRPr lang="en-US" sz="4000" dirty="0"/>
-          </a:p>
-        </p:txBody>
-      </p:sp>
-      <p:sp>
-        <p:nvSpPr>
-          <p:cNvPr id="30" name="stat label data checks without a failure"/>
+              <a:t>8 pass · 1 warning</a:t>
+            </a:r>
+            <a:endParaRPr lang="en-US" sz="2600" dirty="0"/>
+          </a:p>
+        </p:txBody>
+      </p:sp>
+      <p:sp>
+        <p:nvSpPr>
+          <p:cNvPr id="30" name="stat label of 9 data checks; the warning (V8) flags 61 outlier observations, kept, not dropped"/>
           <p:cNvSpPr txBox="1"/>
           <p:nvPr/>
         </p:nvSpPr>
         <p:spPr>
           <a:xfrm>
-            <a:off x="8549640" y="2743200"/>
+            <a:off x="8549640" y="2487168"/>
             <a:ext cx="2834640" cy="548640"/>
           </a:xfrm>
           <a:prstGeom prst="rect">
@@ -5315,7 +5523,7 @@
                   <a:schemeClr val="accent3"/>
                 </a:solidFill>
               </a:rPr>
-              <a:t>data checks without a failure</a:t>
+              <a:t>of 9 data checks; the warning (V8) flags 61 outlier observations, kept, not dropped</a:t>
             </a:r>
             <a:endParaRPr lang="en-US" sz="1300" dirty="0"/>
           </a:p>
@@ -5712,7 +5920,7 @@
       </p:sp>
       <p:sp>
         <p:nvSpPr>
-          <p:cNvPr id="7" name="stat Diebold-Mariano p (198 origins)"/>
+          <p:cNvPr id="7" name="stat raw Diebold-Mariano p, 198 origins; Holm-adjusted 0.049"/>
           <p:cNvSpPr txBox="1"/>
           <p:nvPr/>
         </p:nvSpPr>
@@ -5751,7 +5959,7 @@
       </p:sp>
       <p:sp>
         <p:nvSpPr>
-          <p:cNvPr id="8" name="stat label Diebold-Mariano p (198 origins)"/>
+          <p:cNvPr id="8" name="stat label raw Diebold-Mariano p, 198 origins; Holm-adjusted 0.049"/>
           <p:cNvSpPr txBox="1"/>
           <p:nvPr/>
         </p:nvSpPr>
@@ -5779,7 +5987,7 @@
                   <a:schemeClr val="accent3"/>
                 </a:solidFill>
               </a:rPr>
-              <a:t>Diebold-Mariano p (198 origins)</a:t>
+              <a:t>raw Diebold-Mariano p, 198 origins; Holm-adjusted 0.049</a:t>
             </a:r>
             <a:endParaRPr lang="en-US" sz="1300" dirty="0"/>
           </a:p>
@@ -5840,12 +6048,12 @@
         </p:nvSpPr>
         <p:spPr>
           <a:xfrm>
-            <a:off x="6675120" y="4023360"/>
-            <a:ext cx="4965192" cy="2011680"/>
+            <a:off x="6675120" y="3931920"/>
+            <a:ext cx="4965192" cy="2148840"/>
           </a:xfrm>
           <a:prstGeom prst="roundRect">
             <a:avLst>
-              <a:gd name="adj" fmla="val 5455"/>
+              <a:gd name="adj" fmla="val 5106"/>
             </a:avLst>
           </a:prstGeom>
           <a:solidFill>
@@ -5867,7 +6075,7 @@
         </p:nvSpPr>
         <p:spPr>
           <a:xfrm>
-            <a:off x="6903720" y="4160520"/>
+            <a:off x="6903720" y="4041648"/>
             <a:ext cx="4572000" cy="320040"/>
           </a:xfrm>
           <a:prstGeom prst="rect">
@@ -5903,8 +6111,8 @@
         </p:nvSpPr>
         <p:spPr>
           <a:xfrm>
-            <a:off x="6903720" y="4526280"/>
-            <a:ext cx="4572000" cy="1463040"/>
+            <a:off x="6903720" y="4389120"/>
+            <a:ext cx="4572000" cy="1645920"/>
           </a:xfrm>
           <a:prstGeom prst="rect">
             <a:avLst/>
@@ -5928,7 +6136,7 @@
                   <a:schemeClr val="tx1"/>
                 </a:solidFill>
               </a:rPr>
-              <a:t>In 2020–23 only 35% of outcomes fell inside the 68% band (79% in 2010–19), and the model under-predicted by 0.37 pp on average.</a:t>
+              <a:t>2020–23: only 35% of outcomes inside the 68% band (79% in 2010–19); under-prediction 0.37 pp on average.</a:t>
             </a:r>
             <a:endParaRPr lang="en-US" sz="1300" dirty="0"/>
           </a:p>
@@ -5962,7 +6170,7 @@
                   <a:schemeClr val="tx1"/>
                 </a:solidFill>
               </a:rPr>
-              <a:t>Model frozen after 4 pre-registered rounds; the ledger now scores it out of sample.</a:t>
+              <a:t>The backtest uses latest-vintage data, and the model was chosen on the same history; the ledger scores it prospectively from the freeze, 21 Oct 2026.</a:t>
             </a:r>
             <a:endParaRPr lang="en-US" sz="1300" dirty="0"/>
           </a:p>
@@ -6071,7 +6279,7 @@
                 <a:ea typeface="Calibri" pitchFamily="34" charset="-122"/>
                 <a:cs typeface="Calibri" pitchFamily="34" charset="-120"/>
               </a:rPr>
-              <a:t>Shock pass-through · preset scenario</a:t>
+              <a:t>Shock pass-through · European gas price spike preset</a:t>
             </a:r>
             <a:endParaRPr lang="en-US" sz="1400" dirty="0"/>
           </a:p>
@@ -6110,7 +6318,7 @@
                 <a:ea typeface="Cambria" pitchFamily="34" charset="-122"/>
                 <a:cs typeface="Cambria" pitchFamily="34" charset="-120"/>
               </a:rPr>
-              <a:t>A gas price spike would add up to +1.07 pp to headline</a:t>
+              <a:t>Gas price shock adds up to +1.07 pp</a:t>
             </a:r>
             <a:endParaRPr lang="en-US" sz="3400" dirty="0"/>
           </a:p>
@@ -6821,7 +7029,7 @@
                   <a:schemeClr val="accent2"/>
                 </a:solidFill>
               </a:rPr>
-              <a:t>Ask it anything</a:t>
+              <a:t>Ask about the dashboard</a:t>
             </a:r>
             <a:endParaRPr lang="en-US" sz="1500" dirty="0"/>
           </a:p>
@@ -6857,7 +7065,7 @@
                   <a:schemeClr val="bg2"/>
                 </a:solidFill>
               </a:rPr>
-              <a:t>A chatbot answers in EN, FR or Turkish; every number is checked against the page, and it builds and runs scenarios itself.</a:t>
+              <a:t>A chatbot answers in EN, FR or Turkish, checks each number it quotes against the page, and builds and runs scenarios itself.</a:t>
             </a:r>
             <a:endParaRPr lang="en-US" sz="1200" dirty="0"/>
           </a:p>
@@ -7118,7 +7326,7 @@
                   <a:schemeClr val="accent2"/>
                 </a:solidFill>
               </a:rPr>
-              <a:t>Forecasts that keep score</a:t>
+              <a:t>Forecast tracking</a:t>
             </a:r>
             <a:endParaRPr lang="en-US" sz="1500" dirty="0"/>
           </a:p>
@@ -7154,7 +7362,7 @@
                   <a:schemeClr val="bg2"/>
                 </a:solidFill>
               </a:rPr>
-              <a:t>Pre-registered model rounds and a hash-chained ledger scored as Eurostat publishes.</a:t>
+              <a:t>Pre-registered model rounds and a hash-chained ledger, scored as Eurostat publishes.</a:t>
             </a:r>
             <a:endParaRPr lang="en-US" sz="1200" dirty="0"/>
           </a:p>

</xml_diff>

<commit_message>
Deck: no outline on the fan's area series (thin lines in PowerPoint), two-line checks figure, 'Ask EuroPulse' (D72)
Co-Authored-By: Claude Opus 5.5 <noreply@anthropic.com>
</commit_message>
<xml_diff>
--- a/deck/deck.pptx
+++ b/deck/deck.pptx
@@ -111,27 +111,27 @@
   <p:extLst>
     <p:ext uri="{521415D9-36F7-43E2-AB2F-B90AF26B5E84}">
       <p14:sectionLst xmlns:p14="http://schemas.microsoft.com/office/powerpoint/2010/main">
-        <p14:section name="Answer" id="{2546a710-8138-4943-0690-62af48822cc5}">
+        <p14:section name="Answer" id="{6ff1cb44-12f5-2a62-13b5-e70695f5ba44}">
           <p14:sldIdLst>
             <p14:sldId id="256"/>
           </p14:sldIdLst>
         </p14:section>
-        <p14:section name="Method" id="{1a33c276-25d6-7a57-c7ce-7526f8e53f4b}">
+        <p14:section name="Method" id="{e10bd9ab-5186-23cb-f227-202428c3ebfe}">
           <p14:sldIdLst>
             <p14:sldId id="257"/>
           </p14:sldIdLst>
         </p14:section>
-        <p14:section name="Accuracy" id="{8710abb4-968d-baaa-16ec-48c1cf1cb4e1}">
+        <p14:section name="Accuracy" id="{f55d2359-d028-ae93-353d-aca90f855a31}">
           <p14:sldIdLst>
             <p14:sldId id="258"/>
           </p14:sldIdLst>
         </p14:section>
-        <p14:section name="Shocks" id="{a7596c83-4191-1c61-b00b-3cec8344c036}">
+        <p14:section name="Shocks" id="{83b01ab5-32bc-2f4b-4d84-4d565cdca151}">
           <p14:sldIdLst>
             <p14:sldId id="259"/>
           </p14:sldIdLst>
         </p14:section>
-        <p14:section name="Dashboard" id="{63827812-e1aa-87b7-e47a-976ef9599b8a}">
+        <p14:section name="Dashboard" id="{5ac62619-45f7-4559-9188-6e7626a55227}">
           <p14:sldIdLst>
             <p14:sldId id="260"/>
           </p14:sldIdLst>
@@ -203,6 +203,9 @@
             <a:solidFill>
               <a:srgbClr val="FFFFFF"/>
             </a:solidFill>
+            <a:ln>
+              <a:noFill/>
+            </a:ln>
             <a:effectLst/>
           </c:spPr>
           <c:invertIfNegative val="0"/>
@@ -430,6 +433,9 @@
             <a:solidFill>
               <a:srgbClr val="C9DCF4"/>
             </a:solidFill>
+            <a:ln>
+              <a:noFill/>
+            </a:ln>
             <a:effectLst/>
           </c:spPr>
           <c:invertIfNegative val="0"/>
@@ -657,6 +663,9 @@
             <a:solidFill>
               <a:srgbClr val="8FB8EA"/>
             </a:solidFill>
+            <a:ln>
+              <a:noFill/>
+            </a:ln>
             <a:effectLst/>
           </c:spPr>
           <c:invertIfNegative val="0"/>
@@ -884,6 +893,9 @@
             <a:solidFill>
               <a:srgbClr val="C9DCF4"/>
             </a:solidFill>
+            <a:ln>
+              <a:noFill/>
+            </a:ln>
             <a:effectLst/>
           </c:spPr>
           <c:invertIfNegative val="0"/>
@@ -1180,7 +1192,7 @@
             <c:size val="6"/>
             <c:spPr>
               <a:solidFill>
-                <a:srgbClr val="2A78D6"/>
+                <a:srgbClr val="0F1B2D"/>
               </a:solidFill>
               <a:ln w="9525" cap="flat">
                 <a:solidFill>
@@ -1423,7 +1435,7 @@
             <c:size val="6"/>
             <c:spPr>
               <a:solidFill>
-                <a:srgbClr val="0F1B2D"/>
+                <a:srgbClr val="2A78D6"/>
               </a:solidFill>
               <a:ln w="9525" cap="flat">
                 <a:solidFill>
@@ -5456,14 +5468,14 @@
       </p:sp>
       <p:sp>
         <p:nvSpPr>
-          <p:cNvPr id="29" name="stat of 9 data checks; the warning (V8) flags 61 outlier observations, kept, not dropped"/>
+          <p:cNvPr id="29" name="stat checks pass"/>
           <p:cNvSpPr txBox="1"/>
           <p:nvPr/>
         </p:nvSpPr>
         <p:spPr>
           <a:xfrm>
-            <a:off x="8549640" y="2011680"/>
-            <a:ext cx="2834640" cy="685800"/>
+            <a:off x="8549640" y="1965960"/>
+            <a:ext cx="2834640" cy="566928"/>
           </a:xfrm>
           <a:prstGeom prst="rect">
             <a:avLst/>
@@ -5479,7 +5491,7 @@
               <a:buNone/>
             </a:pPr>
             <a:r>
-              <a:rPr lang="en-US" sz="2600" b="1" dirty="0">
+              <a:rPr lang="en-US" sz="3400" b="1" dirty="0">
                 <a:solidFill>
                   <a:schemeClr val="accent1"/>
                 </a:solidFill>
@@ -5487,22 +5499,22 @@
                 <a:ea typeface="Cambria" pitchFamily="34" charset="-122"/>
                 <a:cs typeface="Cambria" pitchFamily="34" charset="-120"/>
               </a:rPr>
-              <a:t>8 pass · 1 warning</a:t>
-            </a:r>
-            <a:endParaRPr lang="en-US" sz="2600" dirty="0"/>
-          </a:p>
-        </p:txBody>
-      </p:sp>
-      <p:sp>
-        <p:nvSpPr>
-          <p:cNvPr id="30" name="stat label of 9 data checks; the warning (V8) flags 61 outlier observations, kept, not dropped"/>
+              <a:t>8 pass</a:t>
+            </a:r>
+            <a:endParaRPr lang="en-US" sz="3400" dirty="0"/>
+          </a:p>
+        </p:txBody>
+      </p:sp>
+      <p:sp>
+        <p:nvSpPr>
+          <p:cNvPr id="30" name="stat checks warning"/>
           <p:cNvSpPr txBox="1"/>
           <p:nvPr/>
         </p:nvSpPr>
         <p:spPr>
           <a:xfrm>
-            <a:off x="8549640" y="2487168"/>
-            <a:ext cx="2834640" cy="548640"/>
+            <a:off x="8549640" y="2542032"/>
+            <a:ext cx="2834640" cy="365760"/>
           </a:xfrm>
           <a:prstGeom prst="rect">
             <a:avLst/>
@@ -5518,27 +5530,27 @@
               <a:buNone/>
             </a:pPr>
             <a:r>
-              <a:rPr lang="en-US" sz="1300" dirty="0">
-                <a:solidFill>
-                  <a:schemeClr val="accent3"/>
-                </a:solidFill>
-              </a:rPr>
-              <a:t>of 9 data checks; the warning (V8) flags 61 outlier observations, kept, not dropped</a:t>
-            </a:r>
-            <a:endParaRPr lang="en-US" sz="1300" dirty="0"/>
-          </a:p>
-        </p:txBody>
-      </p:sp>
-      <p:sp>
-        <p:nvSpPr>
-          <p:cNvPr id="31" name="stat largest error rebuilding Eurostat&amp;apos;s headline"/>
+              <a:rPr lang="en-US" sz="1800" b="1" dirty="0">
+                <a:solidFill>
+                  <a:schemeClr val="accent2"/>
+                </a:solidFill>
+              </a:rPr>
+              <a:t>1 warning (V8)</a:t>
+            </a:r>
+            <a:endParaRPr lang="en-US" sz="1800" dirty="0"/>
+          </a:p>
+        </p:txBody>
+      </p:sp>
+      <p:sp>
+        <p:nvSpPr>
+          <p:cNvPr id="31" name="stat checks label"/>
           <p:cNvSpPr txBox="1"/>
           <p:nvPr/>
         </p:nvSpPr>
         <p:spPr>
           <a:xfrm>
-            <a:off x="8549640" y="3337560"/>
-            <a:ext cx="2834640" cy="685800"/>
+            <a:off x="8549640" y="2926080"/>
+            <a:ext cx="2834640" cy="566928"/>
           </a:xfrm>
           <a:prstGeom prst="rect">
             <a:avLst/>
@@ -5554,7 +5566,43 @@
               <a:buNone/>
             </a:pPr>
             <a:r>
-              <a:rPr lang="en-US" sz="4000" b="1" dirty="0">
+              <a:rPr lang="en-US" sz="1300" dirty="0">
+                <a:solidFill>
+                  <a:schemeClr val="accent3"/>
+                </a:solidFill>
+              </a:rPr>
+              <a:t>of 9 data checks; V8 flags 61 outlier observations, kept, not dropped</a:t>
+            </a:r>
+            <a:endParaRPr lang="en-US" sz="1300" dirty="0"/>
+          </a:p>
+        </p:txBody>
+      </p:sp>
+      <p:sp>
+        <p:nvSpPr>
+          <p:cNvPr id="32" name="stat largest error rebuilding Eurostat&amp;apos;s headline"/>
+          <p:cNvSpPr txBox="1"/>
+          <p:nvPr/>
+        </p:nvSpPr>
+        <p:spPr>
+          <a:xfrm>
+            <a:off x="8549640" y="3639312"/>
+            <a:ext cx="2834640" cy="685800"/>
+          </a:xfrm>
+          <a:prstGeom prst="rect">
+            <a:avLst/>
+          </a:prstGeom>
+          <a:noFill/>
+          <a:ln/>
+        </p:spPr>
+        <p:txBody>
+          <a:bodyPr wrap="square" lIns="0" tIns="0" rIns="0" bIns="0" rtlCol="0" anchor="t"/>
+          <a:lstStyle/>
+          <a:p>
+            <a:pPr indent="0" marL="0">
+              <a:buNone/>
+            </a:pPr>
+            <a:r>
+              <a:rPr lang="en-US" sz="3200" b="1" dirty="0">
                 <a:solidFill>
                   <a:schemeClr val="accent1"/>
                 </a:solidFill>
@@ -5564,19 +5612,19 @@
               </a:rPr>
               <a:t>0.030 pp</a:t>
             </a:r>
-            <a:endParaRPr lang="en-US" sz="4000" dirty="0"/>
-          </a:p>
-        </p:txBody>
-      </p:sp>
-      <p:sp>
-        <p:nvSpPr>
-          <p:cNvPr id="32" name="stat label largest error rebuilding Eurostat&amp;apos;s headline"/>
+            <a:endParaRPr lang="en-US" sz="3200" dirty="0"/>
+          </a:p>
+        </p:txBody>
+      </p:sp>
+      <p:sp>
+        <p:nvSpPr>
+          <p:cNvPr id="33" name="stat label largest error rebuilding Eurostat&amp;apos;s headline"/>
           <p:cNvSpPr txBox="1"/>
           <p:nvPr/>
         </p:nvSpPr>
         <p:spPr>
           <a:xfrm>
-            <a:off x="8549640" y="4069080"/>
+            <a:off x="8549640" y="4224528"/>
             <a:ext cx="2834640" cy="548640"/>
           </a:xfrm>
           <a:prstGeom prst="rect">
@@ -5606,13 +5654,13 @@
       </p:sp>
       <p:sp>
         <p:nvSpPr>
-          <p:cNvPr id="33" name="stat automated tests (maths, data contracts, engine parity)"/>
+          <p:cNvPr id="34" name="stat automated tests (maths, data contracts, engine parity)"/>
           <p:cNvSpPr txBox="1"/>
           <p:nvPr/>
         </p:nvSpPr>
         <p:spPr>
           <a:xfrm>
-            <a:off x="8549640" y="4663440"/>
+            <a:off x="8549640" y="4828032"/>
             <a:ext cx="2834640" cy="685800"/>
           </a:xfrm>
           <a:prstGeom prst="rect">
@@ -5629,7 +5677,7 @@
               <a:buNone/>
             </a:pPr>
             <a:r>
-              <a:rPr lang="en-US" sz="4000" b="1" dirty="0">
+              <a:rPr lang="en-US" sz="3200" b="1" dirty="0">
                 <a:solidFill>
                   <a:schemeClr val="accent1"/>
                 </a:solidFill>
@@ -5639,19 +5687,19 @@
               </a:rPr>
               <a:t>217</a:t>
             </a:r>
-            <a:endParaRPr lang="en-US" sz="4000" dirty="0"/>
-          </a:p>
-        </p:txBody>
-      </p:sp>
-      <p:sp>
-        <p:nvSpPr>
-          <p:cNvPr id="34" name="stat label automated tests (maths, data contracts, engine parity)"/>
+            <a:endParaRPr lang="en-US" sz="3200" dirty="0"/>
+          </a:p>
+        </p:txBody>
+      </p:sp>
+      <p:sp>
+        <p:nvSpPr>
+          <p:cNvPr id="35" name="stat label automated tests (maths, data contracts, engine parity)"/>
           <p:cNvSpPr txBox="1"/>
           <p:nvPr/>
         </p:nvSpPr>
         <p:spPr>
           <a:xfrm>
-            <a:off x="8549640" y="5394960"/>
+            <a:off x="8549640" y="5413248"/>
             <a:ext cx="2834640" cy="548640"/>
           </a:xfrm>
           <a:prstGeom prst="rect">
@@ -7029,7 +7077,7 @@
                   <a:schemeClr val="accent2"/>
                 </a:solidFill>
               </a:rPr>
-              <a:t>Ask about the dashboard</a:t>
+              <a:t>Ask EuroPulse</a:t>
             </a:r>
             <a:endParaRPr lang="en-US" sz="1500" dirty="0"/>
           </a:p>

</xml_diff>

<commit_message>
Deck: slide 1's fan drawn from the data as an image (no band-edge lines in any viewer), Dec 26 label and forecast divider; clearer slide 4 assumption (D72)
Co-Authored-By: Claude Opus 5.5 <noreply@anthropic.com>
</commit_message>
<xml_diff>
--- a/deck/deck.pptx
+++ b/deck/deck.pptx
@@ -111,27 +111,27 @@
   <p:extLst>
     <p:ext uri="{521415D9-36F7-43E2-AB2F-B90AF26B5E84}">
       <p14:sectionLst xmlns:p14="http://schemas.microsoft.com/office/powerpoint/2010/main">
-        <p14:section name="Answer" id="{6ff1cb44-12f5-2a62-13b5-e70695f5ba44}">
+        <p14:section name="Answer" id="{24e05acb-9a74-8641-b02d-767452352337}">
           <p14:sldIdLst>
             <p14:sldId id="256"/>
           </p14:sldIdLst>
         </p14:section>
-        <p14:section name="Method" id="{e10bd9ab-5186-23cb-f227-202428c3ebfe}">
+        <p14:section name="Method" id="{6af8d8c2-93dd-c492-13dc-ec4adff24230}">
           <p14:sldIdLst>
             <p14:sldId id="257"/>
           </p14:sldIdLst>
         </p14:section>
-        <p14:section name="Accuracy" id="{f55d2359-d028-ae93-353d-aca90f855a31}">
+        <p14:section name="Accuracy" id="{93a03333-40f5-45e2-8513-ca7a7d0d6160}">
           <p14:sldIdLst>
             <p14:sldId id="258"/>
           </p14:sldIdLst>
         </p14:section>
-        <p14:section name="Shocks" id="{83b01ab5-32bc-2f4b-4d84-4d565cdca151}">
+        <p14:section name="Shocks" id="{ecd7c7d8-5597-e07e-6a8a-3652fee1b4bd}">
           <p14:sldIdLst>
             <p14:sldId id="259"/>
           </p14:sldIdLst>
         </p14:section>
-        <p14:section name="Dashboard" id="{5ac62619-45f7-4559-9188-6e7626a55227}">
+        <p14:section name="Dashboard" id="{eeda1b63-8cf1-29c8-5dad-1b501bb0b051}">
           <p14:sldIdLst>
             <p14:sldId id="260"/>
           </p14:sldIdLst>
@@ -146,1558 +146,6 @@
 </file>
 
 <file path=ppt/charts/chart1.xml><?xml version="1.0" encoding="utf-8"?>
-<c:chartSpace xmlns:c="http://schemas.openxmlformats.org/drawingml/2006/chart" xmlns:a="http://schemas.openxmlformats.org/drawingml/2006/main" xmlns:r="http://schemas.openxmlformats.org/officeDocument/2006/relationships">
-  <c:date1904 val="0"/>
-  <c:roundedCorners val="1"/>
-  <c:chart>
-    <c:title>
-      <c:tx>
-        <c:rich>
-          <a:bodyPr/>
-          <a:lstStyle/>
-          <a:p>
-            <a:pPr>
-              <a:defRPr sz="1300" b="0" i="0" u="none" strike="noStrike">
-                <a:solidFill>
-                  <a:srgbClr val="14284B"/>
-                </a:solidFill>
-                <a:latin typeface="+mn-lt"/>
-              </a:defRPr>
-            </a:pPr>
-            <a:r>
-              <a:rPr sz="1300" b="0" i="0" u="none" strike="noStrike">
-                <a:solidFill>
-                  <a:srgbClr val="14284B"/>
-                </a:solidFill>
-                <a:latin typeface="+mn-lt"/>
-              </a:rPr>
-              <a:t>Headline HICP, % y/y: last 24 months and the forecast fan</a:t>
-            </a:r>
-          </a:p>
-        </c:rich>
-      </c:tx>
-      <c:layout/>
-      <c:overlay val="0"/>
-    </c:title>
-    <c:autoTitleDeleted val="0"/>
-    <c:plotArea>
-      <c:layout/>
-      <c:areaChart>
-        <c:grouping val="stacked"/>
-        <c:varyColors val="0"/>
-        <c:ser>
-          <c:idx val="0"/>
-          <c:order val="0"/>
-          <c:tx>
-            <c:strRef>
-              <c:f>Sheet1!$B$1</c:f>
-              <c:strCache>
-                <c:ptCount val="1"/>
-                <c:pt idx="0">
-                  <c:v>base</c:v>
-                </c:pt>
-              </c:strCache>
-            </c:strRef>
-          </c:tx>
-          <c:spPr>
-            <a:solidFill>
-              <a:srgbClr val="FFFFFF"/>
-            </a:solidFill>
-            <a:ln>
-              <a:noFill/>
-            </a:ln>
-            <a:effectLst/>
-          </c:spPr>
-          <c:invertIfNegative val="0"/>
-          <c:dLbls>
-            <c:numFmt formatCode="#,##0" sourceLinked="0"/>
-            <c:txPr>
-              <a:bodyPr/>
-              <a:lstStyle/>
-              <a:p>
-                <a:pPr>
-                  <a:defRPr b="0" i="0" strike="noStrike" sz="1200" u="none">
-                    <a:solidFill>
-                      <a:srgbClr val="000000"/>
-                    </a:solidFill>
-                    <a:latin typeface="+mn-lt"/>
-                  </a:defRPr>
-                </a:pPr>
-              </a:p>
-            </c:txPr>
-            <c:showLegendKey val="0"/>
-            <c:showVal val="0"/>
-            <c:showCatName val="0"/>
-            <c:showSerName val="0"/>
-            <c:showPercent val="0"/>
-            <c:showBubbleSize val="0"/>
-            <c:showLeaderLines val="0"/>
-          </c:dLbls>
-          <c:cat>
-            <c:multiLvlStrRef>
-              <c:f>Sheet1!$A$2:$A$28</c:f>
-              <c:multiLvlStrCache>
-                <c:ptCount val="27"/>
-                <c:lvl>
-                  <c:pt idx="0">
-                    <c:v>Oct 24</c:v>
-                  </c:pt>
-                  <c:pt idx="1">
-                    <c:v>Nov 24</c:v>
-                  </c:pt>
-                  <c:pt idx="2">
-                    <c:v>Dec 24</c:v>
-                  </c:pt>
-                  <c:pt idx="3">
-                    <c:v>Jan 25</c:v>
-                  </c:pt>
-                  <c:pt idx="4">
-                    <c:v>Feb 25</c:v>
-                  </c:pt>
-                  <c:pt idx="5">
-                    <c:v>Mar 25</c:v>
-                  </c:pt>
-                  <c:pt idx="6">
-                    <c:v>Apr 25</c:v>
-                  </c:pt>
-                  <c:pt idx="7">
-                    <c:v>May 25</c:v>
-                  </c:pt>
-                  <c:pt idx="8">
-                    <c:v>Jun 25</c:v>
-                  </c:pt>
-                  <c:pt idx="9">
-                    <c:v>Jul 25</c:v>
-                  </c:pt>
-                  <c:pt idx="10">
-                    <c:v>Aug 25</c:v>
-                  </c:pt>
-                  <c:pt idx="11">
-                    <c:v>Sep 25</c:v>
-                  </c:pt>
-                  <c:pt idx="12">
-                    <c:v>Oct 25</c:v>
-                  </c:pt>
-                  <c:pt idx="13">
-                    <c:v>Nov 25</c:v>
-                  </c:pt>
-                  <c:pt idx="14">
-                    <c:v>Dec 25</c:v>
-                  </c:pt>
-                  <c:pt idx="15">
-                    <c:v>Jan 26</c:v>
-                  </c:pt>
-                  <c:pt idx="16">
-                    <c:v>Feb 26</c:v>
-                  </c:pt>
-                  <c:pt idx="17">
-                    <c:v>Mar 26</c:v>
-                  </c:pt>
-                  <c:pt idx="18">
-                    <c:v>Apr 26</c:v>
-                  </c:pt>
-                  <c:pt idx="19">
-                    <c:v>May 26</c:v>
-                  </c:pt>
-                  <c:pt idx="20">
-                    <c:v>Jun 26</c:v>
-                  </c:pt>
-                  <c:pt idx="21">
-                    <c:v>Jul 26</c:v>
-                  </c:pt>
-                  <c:pt idx="22">
-                    <c:v>Aug 26</c:v>
-                  </c:pt>
-                  <c:pt idx="23">
-                    <c:v>Sep 26</c:v>
-                  </c:pt>
-                  <c:pt idx="24">
-                    <c:v>Oct 26</c:v>
-                  </c:pt>
-                  <c:pt idx="25">
-                    <c:v>Nov 26</c:v>
-                  </c:pt>
-                  <c:pt idx="26">
-                    <c:v>Dec 26</c:v>
-                  </c:pt>
-                </c:lvl>
-              </c:multiLvlStrCache>
-            </c:multiLvlStrRef>
-          </c:cat>
-          <c:val>
-            <c:numRef>
-              <c:f>Sheet1!$B$2:$B$28</c:f>
-              <c:numCache>
-                <c:formatCode>General</c:formatCode>
-                <c:ptCount val="27"/>
-                <c:pt idx="0">
-                  <c:v>2.0055825493642043</c:v>
-                </c:pt>
-                <c:pt idx="1">
-                  <c:v>2.2455556710676783</c:v>
-                </c:pt>
-                <c:pt idx="2">
-                  <c:v>2.4286455630513792</c:v>
-                </c:pt>
-                <c:pt idx="3">
-                  <c:v>2.5208333333333277</c:v>
-                </c:pt>
-                <c:pt idx="4">
-                  <c:v>2.3188405797101463</c:v>
-                </c:pt>
-                <c:pt idx="5">
-                  <c:v>2.17815678619131</c:v>
-                </c:pt>
-                <c:pt idx="6">
-                  <c:v>2.1656961896005855</c:v>
-                </c:pt>
-                <c:pt idx="7">
-                  <c:v>1.8960244648318136</c:v>
-                </c:pt>
-                <c:pt idx="8">
-                  <c:v>1.9835215135795004</c:v>
-                </c:pt>
-                <c:pt idx="9">
-                  <c:v>2.0347949944043098</c:v>
-                </c:pt>
-                <c:pt idx="10">
-                  <c:v>2.042267831741529</c:v>
-                </c:pt>
-                <c:pt idx="11">
-                  <c:v>2.2271941421743158</c:v>
-                </c:pt>
-                <c:pt idx="12">
-                  <c:v>2.0979020979020824</c:v>
-                </c:pt>
-                <c:pt idx="13">
-                  <c:v>2.135231316725994</c:v>
-                </c:pt>
-                <c:pt idx="14">
-                  <c:v>1.9657513425878959</c:v>
-                </c:pt>
-                <c:pt idx="15">
-                  <c:v>1.6764885185937661</c:v>
-                </c:pt>
-                <c:pt idx="16">
-                  <c:v>1.8919465803318491</c:v>
-                </c:pt>
-                <c:pt idx="17">
-                  <c:v>2.554047259929604</c:v>
-                </c:pt>
-                <c:pt idx="18">
-                  <c:v>3.029697030296963</c:v>
-                </c:pt>
-                <c:pt idx="19">
-                  <c:v>3.171268507402969</c:v>
-                </c:pt>
-                <c:pt idx="20">
-                  <c:v>2.752842609216022</c:v>
-                </c:pt>
-                <c:pt idx="21">
-                  <c:v>2.9414697377604826</c:v>
-                </c:pt>
-                <c:pt idx="22">
-                  <c:v>3.2460420193169304</c:v>
-                </c:pt>
-                <c:pt idx="23">
-                  <c:v>3.7703939514524443</c:v>
-                </c:pt>
-                <c:pt idx="24">
-                  <c:v>3.491592567361237</c:v>
-                </c:pt>
-                <c:pt idx="25">
-                  <c:v>3.093708168999547</c:v>
-                </c:pt>
-                <c:pt idx="26">
-                  <c:v>2.998638531993297</c:v>
-                </c:pt>
-              </c:numCache>
-            </c:numRef>
-          </c:val>
-        </c:ser>
-        <c:ser>
-          <c:idx val="1"/>
-          <c:order val="1"/>
-          <c:tx>
-            <c:strRef>
-              <c:f>Sheet1!$C$1</c:f>
-              <c:strCache>
-                <c:ptCount val="1"/>
-                <c:pt idx="0">
-                  <c:v>90% band</c:v>
-                </c:pt>
-              </c:strCache>
-            </c:strRef>
-          </c:tx>
-          <c:spPr>
-            <a:solidFill>
-              <a:srgbClr val="C9DCF4"/>
-            </a:solidFill>
-            <a:ln>
-              <a:noFill/>
-            </a:ln>
-            <a:effectLst/>
-          </c:spPr>
-          <c:invertIfNegative val="0"/>
-          <c:dLbls>
-            <c:numFmt formatCode="#,##0" sourceLinked="0"/>
-            <c:txPr>
-              <a:bodyPr/>
-              <a:lstStyle/>
-              <a:p>
-                <a:pPr>
-                  <a:defRPr b="0" i="0" strike="noStrike" sz="1200" u="none">
-                    <a:solidFill>
-                      <a:srgbClr val="000000"/>
-                    </a:solidFill>
-                    <a:latin typeface="+mn-lt"/>
-                  </a:defRPr>
-                </a:pPr>
-              </a:p>
-            </c:txPr>
-            <c:showLegendKey val="0"/>
-            <c:showVal val="0"/>
-            <c:showCatName val="0"/>
-            <c:showSerName val="0"/>
-            <c:showPercent val="0"/>
-            <c:showBubbleSize val="0"/>
-            <c:showLeaderLines val="0"/>
-          </c:dLbls>
-          <c:cat>
-            <c:multiLvlStrRef>
-              <c:f>Sheet1!$A$2:$A$28</c:f>
-              <c:multiLvlStrCache>
-                <c:ptCount val="27"/>
-                <c:lvl>
-                  <c:pt idx="0">
-                    <c:v>Oct 24</c:v>
-                  </c:pt>
-                  <c:pt idx="1">
-                    <c:v>Nov 24</c:v>
-                  </c:pt>
-                  <c:pt idx="2">
-                    <c:v>Dec 24</c:v>
-                  </c:pt>
-                  <c:pt idx="3">
-                    <c:v>Jan 25</c:v>
-                  </c:pt>
-                  <c:pt idx="4">
-                    <c:v>Feb 25</c:v>
-                  </c:pt>
-                  <c:pt idx="5">
-                    <c:v>Mar 25</c:v>
-                  </c:pt>
-                  <c:pt idx="6">
-                    <c:v>Apr 25</c:v>
-                  </c:pt>
-                  <c:pt idx="7">
-                    <c:v>May 25</c:v>
-                  </c:pt>
-                  <c:pt idx="8">
-                    <c:v>Jun 25</c:v>
-                  </c:pt>
-                  <c:pt idx="9">
-                    <c:v>Jul 25</c:v>
-                  </c:pt>
-                  <c:pt idx="10">
-                    <c:v>Aug 25</c:v>
-                  </c:pt>
-                  <c:pt idx="11">
-                    <c:v>Sep 25</c:v>
-                  </c:pt>
-                  <c:pt idx="12">
-                    <c:v>Oct 25</c:v>
-                  </c:pt>
-                  <c:pt idx="13">
-                    <c:v>Nov 25</c:v>
-                  </c:pt>
-                  <c:pt idx="14">
-                    <c:v>Dec 25</c:v>
-                  </c:pt>
-                  <c:pt idx="15">
-                    <c:v>Jan 26</c:v>
-                  </c:pt>
-                  <c:pt idx="16">
-                    <c:v>Feb 26</c:v>
-                  </c:pt>
-                  <c:pt idx="17">
-                    <c:v>Mar 26</c:v>
-                  </c:pt>
-                  <c:pt idx="18">
-                    <c:v>Apr 26</c:v>
-                  </c:pt>
-                  <c:pt idx="19">
-                    <c:v>May 26</c:v>
-                  </c:pt>
-                  <c:pt idx="20">
-                    <c:v>Jun 26</c:v>
-                  </c:pt>
-                  <c:pt idx="21">
-                    <c:v>Jul 26</c:v>
-                  </c:pt>
-                  <c:pt idx="22">
-                    <c:v>Aug 26</c:v>
-                  </c:pt>
-                  <c:pt idx="23">
-                    <c:v>Sep 26</c:v>
-                  </c:pt>
-                  <c:pt idx="24">
-                    <c:v>Oct 26</c:v>
-                  </c:pt>
-                  <c:pt idx="25">
-                    <c:v>Nov 26</c:v>
-                  </c:pt>
-                  <c:pt idx="26">
-                    <c:v>Dec 26</c:v>
-                  </c:pt>
-                </c:lvl>
-              </c:multiLvlStrCache>
-            </c:multiLvlStrRef>
-          </c:cat>
-          <c:val>
-            <c:numRef>
-              <c:f>Sheet1!$C$2:$C$28</c:f>
-              <c:numCache>
-                <c:formatCode>General</c:formatCode>
-                <c:ptCount val="27"/>
-                <c:pt idx="0">
-                  <c:v>0</c:v>
-                </c:pt>
-                <c:pt idx="1">
-                  <c:v>0</c:v>
-                </c:pt>
-                <c:pt idx="2">
-                  <c:v>0</c:v>
-                </c:pt>
-                <c:pt idx="3">
-                  <c:v>0</c:v>
-                </c:pt>
-                <c:pt idx="4">
-                  <c:v>0</c:v>
-                </c:pt>
-                <c:pt idx="5">
-                  <c:v>0</c:v>
-                </c:pt>
-                <c:pt idx="6">
-                  <c:v>0</c:v>
-                </c:pt>
-                <c:pt idx="7">
-                  <c:v>0</c:v>
-                </c:pt>
-                <c:pt idx="8">
-                  <c:v>0</c:v>
-                </c:pt>
-                <c:pt idx="9">
-                  <c:v>0</c:v>
-                </c:pt>
-                <c:pt idx="10">
-                  <c:v>0</c:v>
-                </c:pt>
-                <c:pt idx="11">
-                  <c:v>0</c:v>
-                </c:pt>
-                <c:pt idx="12">
-                  <c:v>0</c:v>
-                </c:pt>
-                <c:pt idx="13">
-                  <c:v>0</c:v>
-                </c:pt>
-                <c:pt idx="14">
-                  <c:v>0</c:v>
-                </c:pt>
-                <c:pt idx="15">
-                  <c:v>0</c:v>
-                </c:pt>
-                <c:pt idx="16">
-                  <c:v>0</c:v>
-                </c:pt>
-                <c:pt idx="17">
-                  <c:v>0</c:v>
-                </c:pt>
-                <c:pt idx="18">
-                  <c:v>0</c:v>
-                </c:pt>
-                <c:pt idx="19">
-                  <c:v>0</c:v>
-                </c:pt>
-                <c:pt idx="20">
-                  <c:v>0</c:v>
-                </c:pt>
-                <c:pt idx="21">
-                  <c:v>0</c:v>
-                </c:pt>
-                <c:pt idx="22">
-                  <c:v>0</c:v>
-                </c:pt>
-                <c:pt idx="23">
-                  <c:v>0</c:v>
-                </c:pt>
-                <c:pt idx="24">
-                  <c:v>0.11991664076378328</c:v>
-                </c:pt>
-                <c:pt idx="25">
-                  <c:v>0.3381287395588206</c:v>
-                </c:pt>
-                <c:pt idx="26">
-                  <c:v>0.39984668775426346</c:v>
-                </c:pt>
-              </c:numCache>
-            </c:numRef>
-          </c:val>
-        </c:ser>
-        <c:ser>
-          <c:idx val="2"/>
-          <c:order val="2"/>
-          <c:tx>
-            <c:strRef>
-              <c:f>Sheet1!$D$1</c:f>
-              <c:strCache>
-                <c:ptCount val="1"/>
-                <c:pt idx="0">
-                  <c:v>68% band</c:v>
-                </c:pt>
-              </c:strCache>
-            </c:strRef>
-          </c:tx>
-          <c:spPr>
-            <a:solidFill>
-              <a:srgbClr val="8FB8EA"/>
-            </a:solidFill>
-            <a:ln>
-              <a:noFill/>
-            </a:ln>
-            <a:effectLst/>
-          </c:spPr>
-          <c:invertIfNegative val="0"/>
-          <c:dLbls>
-            <c:numFmt formatCode="#,##0" sourceLinked="0"/>
-            <c:txPr>
-              <a:bodyPr/>
-              <a:lstStyle/>
-              <a:p>
-                <a:pPr>
-                  <a:defRPr b="0" i="0" strike="noStrike" sz="1200" u="none">
-                    <a:solidFill>
-                      <a:srgbClr val="000000"/>
-                    </a:solidFill>
-                    <a:latin typeface="+mn-lt"/>
-                  </a:defRPr>
-                </a:pPr>
-              </a:p>
-            </c:txPr>
-            <c:showLegendKey val="0"/>
-            <c:showVal val="0"/>
-            <c:showCatName val="0"/>
-            <c:showSerName val="0"/>
-            <c:showPercent val="0"/>
-            <c:showBubbleSize val="0"/>
-            <c:showLeaderLines val="0"/>
-          </c:dLbls>
-          <c:cat>
-            <c:multiLvlStrRef>
-              <c:f>Sheet1!$A$2:$A$28</c:f>
-              <c:multiLvlStrCache>
-                <c:ptCount val="27"/>
-                <c:lvl>
-                  <c:pt idx="0">
-                    <c:v>Oct 24</c:v>
-                  </c:pt>
-                  <c:pt idx="1">
-                    <c:v>Nov 24</c:v>
-                  </c:pt>
-                  <c:pt idx="2">
-                    <c:v>Dec 24</c:v>
-                  </c:pt>
-                  <c:pt idx="3">
-                    <c:v>Jan 25</c:v>
-                  </c:pt>
-                  <c:pt idx="4">
-                    <c:v>Feb 25</c:v>
-                  </c:pt>
-                  <c:pt idx="5">
-                    <c:v>Mar 25</c:v>
-                  </c:pt>
-                  <c:pt idx="6">
-                    <c:v>Apr 25</c:v>
-                  </c:pt>
-                  <c:pt idx="7">
-                    <c:v>May 25</c:v>
-                  </c:pt>
-                  <c:pt idx="8">
-                    <c:v>Jun 25</c:v>
-                  </c:pt>
-                  <c:pt idx="9">
-                    <c:v>Jul 25</c:v>
-                  </c:pt>
-                  <c:pt idx="10">
-                    <c:v>Aug 25</c:v>
-                  </c:pt>
-                  <c:pt idx="11">
-                    <c:v>Sep 25</c:v>
-                  </c:pt>
-                  <c:pt idx="12">
-                    <c:v>Oct 25</c:v>
-                  </c:pt>
-                  <c:pt idx="13">
-                    <c:v>Nov 25</c:v>
-                  </c:pt>
-                  <c:pt idx="14">
-                    <c:v>Dec 25</c:v>
-                  </c:pt>
-                  <c:pt idx="15">
-                    <c:v>Jan 26</c:v>
-                  </c:pt>
-                  <c:pt idx="16">
-                    <c:v>Feb 26</c:v>
-                  </c:pt>
-                  <c:pt idx="17">
-                    <c:v>Mar 26</c:v>
-                  </c:pt>
-                  <c:pt idx="18">
-                    <c:v>Apr 26</c:v>
-                  </c:pt>
-                  <c:pt idx="19">
-                    <c:v>May 26</c:v>
-                  </c:pt>
-                  <c:pt idx="20">
-                    <c:v>Jun 26</c:v>
-                  </c:pt>
-                  <c:pt idx="21">
-                    <c:v>Jul 26</c:v>
-                  </c:pt>
-                  <c:pt idx="22">
-                    <c:v>Aug 26</c:v>
-                  </c:pt>
-                  <c:pt idx="23">
-                    <c:v>Sep 26</c:v>
-                  </c:pt>
-                  <c:pt idx="24">
-                    <c:v>Oct 26</c:v>
-                  </c:pt>
-                  <c:pt idx="25">
-                    <c:v>Nov 26</c:v>
-                  </c:pt>
-                  <c:pt idx="26">
-                    <c:v>Dec 26</c:v>
-                  </c:pt>
-                </c:lvl>
-              </c:multiLvlStrCache>
-            </c:multiLvlStrRef>
-          </c:cat>
-          <c:val>
-            <c:numRef>
-              <c:f>Sheet1!$D$2:$D$28</c:f>
-              <c:numCache>
-                <c:formatCode>General</c:formatCode>
-                <c:ptCount val="27"/>
-                <c:pt idx="0">
-                  <c:v>0</c:v>
-                </c:pt>
-                <c:pt idx="1">
-                  <c:v>0</c:v>
-                </c:pt>
-                <c:pt idx="2">
-                  <c:v>0</c:v>
-                </c:pt>
-                <c:pt idx="3">
-                  <c:v>0</c:v>
-                </c:pt>
-                <c:pt idx="4">
-                  <c:v>0</c:v>
-                </c:pt>
-                <c:pt idx="5">
-                  <c:v>0</c:v>
-                </c:pt>
-                <c:pt idx="6">
-                  <c:v>0</c:v>
-                </c:pt>
-                <c:pt idx="7">
-                  <c:v>0</c:v>
-                </c:pt>
-                <c:pt idx="8">
-                  <c:v>0</c:v>
-                </c:pt>
-                <c:pt idx="9">
-                  <c:v>0</c:v>
-                </c:pt>
-                <c:pt idx="10">
-                  <c:v>0</c:v>
-                </c:pt>
-                <c:pt idx="11">
-                  <c:v>0</c:v>
-                </c:pt>
-                <c:pt idx="12">
-                  <c:v>0</c:v>
-                </c:pt>
-                <c:pt idx="13">
-                  <c:v>0</c:v>
-                </c:pt>
-                <c:pt idx="14">
-                  <c:v>0</c:v>
-                </c:pt>
-                <c:pt idx="15">
-                  <c:v>0</c:v>
-                </c:pt>
-                <c:pt idx="16">
-                  <c:v>0</c:v>
-                </c:pt>
-                <c:pt idx="17">
-                  <c:v>0</c:v>
-                </c:pt>
-                <c:pt idx="18">
-                  <c:v>0</c:v>
-                </c:pt>
-                <c:pt idx="19">
-                  <c:v>0</c:v>
-                </c:pt>
-                <c:pt idx="20">
-                  <c:v>0</c:v>
-                </c:pt>
-                <c:pt idx="21">
-                  <c:v>0</c:v>
-                </c:pt>
-                <c:pt idx="22">
-                  <c:v>0</c:v>
-                </c:pt>
-                <c:pt idx="23">
-                  <c:v>0</c:v>
-                </c:pt>
-                <c:pt idx="24">
-                  <c:v>0.3291310199191342</c:v>
-                </c:pt>
-                <c:pt idx="25">
-                  <c:v>0.556852618208695</c:v>
-                </c:pt>
-                <c:pt idx="26">
-                  <c:v>0.8327773611581479</c:v>
-                </c:pt>
-              </c:numCache>
-            </c:numRef>
-          </c:val>
-        </c:ser>
-        <c:ser>
-          <c:idx val="3"/>
-          <c:order val="3"/>
-          <c:tx>
-            <c:strRef>
-              <c:f>Sheet1!$E$1</c:f>
-              <c:strCache>
-                <c:ptCount val="1"/>
-                <c:pt idx="0">
-                  <c:v>90% band upper</c:v>
-                </c:pt>
-              </c:strCache>
-            </c:strRef>
-          </c:tx>
-          <c:spPr>
-            <a:solidFill>
-              <a:srgbClr val="C9DCF4"/>
-            </a:solidFill>
-            <a:ln>
-              <a:noFill/>
-            </a:ln>
-            <a:effectLst/>
-          </c:spPr>
-          <c:invertIfNegative val="0"/>
-          <c:dLbls>
-            <c:numFmt formatCode="#,##0" sourceLinked="0"/>
-            <c:txPr>
-              <a:bodyPr/>
-              <a:lstStyle/>
-              <a:p>
-                <a:pPr>
-                  <a:defRPr b="0" i="0" strike="noStrike" sz="1200" u="none">
-                    <a:solidFill>
-                      <a:srgbClr val="000000"/>
-                    </a:solidFill>
-                    <a:latin typeface="+mn-lt"/>
-                  </a:defRPr>
-                </a:pPr>
-              </a:p>
-            </c:txPr>
-            <c:showLegendKey val="0"/>
-            <c:showVal val="0"/>
-            <c:showCatName val="0"/>
-            <c:showSerName val="0"/>
-            <c:showPercent val="0"/>
-            <c:showBubbleSize val="0"/>
-            <c:showLeaderLines val="0"/>
-          </c:dLbls>
-          <c:cat>
-            <c:multiLvlStrRef>
-              <c:f>Sheet1!$A$2:$A$28</c:f>
-              <c:multiLvlStrCache>
-                <c:ptCount val="27"/>
-                <c:lvl>
-                  <c:pt idx="0">
-                    <c:v>Oct 24</c:v>
-                  </c:pt>
-                  <c:pt idx="1">
-                    <c:v>Nov 24</c:v>
-                  </c:pt>
-                  <c:pt idx="2">
-                    <c:v>Dec 24</c:v>
-                  </c:pt>
-                  <c:pt idx="3">
-                    <c:v>Jan 25</c:v>
-                  </c:pt>
-                  <c:pt idx="4">
-                    <c:v>Feb 25</c:v>
-                  </c:pt>
-                  <c:pt idx="5">
-                    <c:v>Mar 25</c:v>
-                  </c:pt>
-                  <c:pt idx="6">
-                    <c:v>Apr 25</c:v>
-                  </c:pt>
-                  <c:pt idx="7">
-                    <c:v>May 25</c:v>
-                  </c:pt>
-                  <c:pt idx="8">
-                    <c:v>Jun 25</c:v>
-                  </c:pt>
-                  <c:pt idx="9">
-                    <c:v>Jul 25</c:v>
-                  </c:pt>
-                  <c:pt idx="10">
-                    <c:v>Aug 25</c:v>
-                  </c:pt>
-                  <c:pt idx="11">
-                    <c:v>Sep 25</c:v>
-                  </c:pt>
-                  <c:pt idx="12">
-                    <c:v>Oct 25</c:v>
-                  </c:pt>
-                  <c:pt idx="13">
-                    <c:v>Nov 25</c:v>
-                  </c:pt>
-                  <c:pt idx="14">
-                    <c:v>Dec 25</c:v>
-                  </c:pt>
-                  <c:pt idx="15">
-                    <c:v>Jan 26</c:v>
-                  </c:pt>
-                  <c:pt idx="16">
-                    <c:v>Feb 26</c:v>
-                  </c:pt>
-                  <c:pt idx="17">
-                    <c:v>Mar 26</c:v>
-                  </c:pt>
-                  <c:pt idx="18">
-                    <c:v>Apr 26</c:v>
-                  </c:pt>
-                  <c:pt idx="19">
-                    <c:v>May 26</c:v>
-                  </c:pt>
-                  <c:pt idx="20">
-                    <c:v>Jun 26</c:v>
-                  </c:pt>
-                  <c:pt idx="21">
-                    <c:v>Jul 26</c:v>
-                  </c:pt>
-                  <c:pt idx="22">
-                    <c:v>Aug 26</c:v>
-                  </c:pt>
-                  <c:pt idx="23">
-                    <c:v>Sep 26</c:v>
-                  </c:pt>
-                  <c:pt idx="24">
-                    <c:v>Oct 26</c:v>
-                  </c:pt>
-                  <c:pt idx="25">
-                    <c:v>Nov 26</c:v>
-                  </c:pt>
-                  <c:pt idx="26">
-                    <c:v>Dec 26</c:v>
-                  </c:pt>
-                </c:lvl>
-              </c:multiLvlStrCache>
-            </c:multiLvlStrRef>
-          </c:cat>
-          <c:val>
-            <c:numRef>
-              <c:f>Sheet1!$E$2:$E$28</c:f>
-              <c:numCache>
-                <c:formatCode>General</c:formatCode>
-                <c:ptCount val="27"/>
-                <c:pt idx="0">
-                  <c:v>0</c:v>
-                </c:pt>
-                <c:pt idx="1">
-                  <c:v>0</c:v>
-                </c:pt>
-                <c:pt idx="2">
-                  <c:v>0</c:v>
-                </c:pt>
-                <c:pt idx="3">
-                  <c:v>0</c:v>
-                </c:pt>
-                <c:pt idx="4">
-                  <c:v>0</c:v>
-                </c:pt>
-                <c:pt idx="5">
-                  <c:v>0</c:v>
-                </c:pt>
-                <c:pt idx="6">
-                  <c:v>0</c:v>
-                </c:pt>
-                <c:pt idx="7">
-                  <c:v>0</c:v>
-                </c:pt>
-                <c:pt idx="8">
-                  <c:v>0</c:v>
-                </c:pt>
-                <c:pt idx="9">
-                  <c:v>0</c:v>
-                </c:pt>
-                <c:pt idx="10">
-                  <c:v>0</c:v>
-                </c:pt>
-                <c:pt idx="11">
-                  <c:v>0</c:v>
-                </c:pt>
-                <c:pt idx="12">
-                  <c:v>0</c:v>
-                </c:pt>
-                <c:pt idx="13">
-                  <c:v>0</c:v>
-                </c:pt>
-                <c:pt idx="14">
-                  <c:v>0</c:v>
-                </c:pt>
-                <c:pt idx="15">
-                  <c:v>0</c:v>
-                </c:pt>
-                <c:pt idx="16">
-                  <c:v>0</c:v>
-                </c:pt>
-                <c:pt idx="17">
-                  <c:v>0</c:v>
-                </c:pt>
-                <c:pt idx="18">
-                  <c:v>0</c:v>
-                </c:pt>
-                <c:pt idx="19">
-                  <c:v>0</c:v>
-                </c:pt>
-                <c:pt idx="20">
-                  <c:v>0</c:v>
-                </c:pt>
-                <c:pt idx="21">
-                  <c:v>0</c:v>
-                </c:pt>
-                <c:pt idx="22">
-                  <c:v>0</c:v>
-                </c:pt>
-                <c:pt idx="23">
-                  <c:v>0</c:v>
-                </c:pt>
-                <c:pt idx="24">
-                  <c:v>0.2591541155889674</c:v>
-                </c:pt>
-                <c:pt idx="25">
-                  <c:v>0.5494988675439858</c:v>
-                </c:pt>
-                <c:pt idx="26">
-                  <c:v>0.843272340756215</c:v>
-                </c:pt>
-              </c:numCache>
-            </c:numRef>
-          </c:val>
-        </c:ser>
-        <c:dLbls>
-          <c:numFmt formatCode="#,##0" sourceLinked="0"/>
-          <c:txPr>
-            <a:bodyPr/>
-            <a:lstStyle/>
-            <a:p>
-              <a:pPr>
-                <a:defRPr b="0" i="0" strike="noStrike" sz="1200" u="none">
-                  <a:solidFill>
-                    <a:srgbClr val="000000"/>
-                  </a:solidFill>
-                  <a:latin typeface="+mn-lt"/>
-                </a:defRPr>
-              </a:pPr>
-            </a:p>
-          </c:txPr>
-          <c:showLegendKey val="0"/>
-          <c:showVal val="0"/>
-          <c:showCatName val="0"/>
-          <c:showSerName val="0"/>
-          <c:showPercent val="0"/>
-          <c:showBubbleSize val="0"/>
-          <c:showLeaderLines val="0"/>
-        </c:dLbls>
-        <c:axId val="2094734554"/>
-        <c:axId val="2094734552"/>
-        <c:axId val="2094734556"/>
-      </c:areaChart>
-      <c:lineChart>
-        <c:varyColors val="0"/>
-        <c:ser>
-          <c:idx val="4"/>
-          <c:order val="4"/>
-          <c:tx>
-            <c:strRef>
-              <c:f>Sheet1!$F$1</c:f>
-              <c:strCache>
-                <c:ptCount val="1"/>
-                <c:pt idx="0">
-                  <c:v>Actual</c:v>
-                </c:pt>
-              </c:strCache>
-            </c:strRef>
-          </c:tx>
-          <c:spPr>
-            <a:solidFill>
-              <a:srgbClr val="0F1B2D"/>
-            </a:solidFill>
-            <a:ln w="28575" cap="flat">
-              <a:solidFill>
-                <a:srgbClr val="0F1B2D"/>
-              </a:solidFill>
-              <a:prstDash val="solid"/>
-              <a:round/>
-            </a:ln>
-            <a:effectLst/>
-          </c:spPr>
-          <c:invertIfNegative val="0"/>
-          <c:dLbls>
-            <c:numFmt formatCode="#,##0" sourceLinked="0"/>
-            <c:txPr>
-              <a:bodyPr/>
-              <a:lstStyle/>
-              <a:p>
-                <a:pPr>
-                  <a:defRPr b="0" i="0" strike="noStrike" sz="1200" u="none">
-                    <a:solidFill>
-                      <a:srgbClr val="000000"/>
-                    </a:solidFill>
-                    <a:latin typeface="+mn-lt"/>
-                  </a:defRPr>
-                </a:pPr>
-              </a:p>
-            </c:txPr>
-            <c:showLegendKey val="0"/>
-            <c:showVal val="0"/>
-            <c:showCatName val="0"/>
-            <c:showSerName val="0"/>
-            <c:showPercent val="0"/>
-            <c:showBubbleSize val="0"/>
-            <c:showLeaderLines val="0"/>
-          </c:dLbls>
-          <c:marker>
-            <c:symbol val="none"/>
-            <c:size val="6"/>
-            <c:spPr>
-              <a:solidFill>
-                <a:srgbClr val="0F1B2D"/>
-              </a:solidFill>
-              <a:ln w="9525" cap="flat">
-                <a:solidFill>
-                  <a:srgbClr val="0F1B2D"/>
-                </a:solidFill>
-                <a:prstDash val="solid"/>
-                <a:round/>
-              </a:ln>
-              <a:effectLst/>
-            </c:spPr>
-          </c:marker>
-          <c:cat>
-            <c:multiLvlStrRef>
-              <c:f>Sheet1!$A$2:$A$28</c:f>
-              <c:multiLvlStrCache>
-                <c:ptCount val="27"/>
-                <c:lvl>
-                  <c:pt idx="0">
-                    <c:v>Oct 24</c:v>
-                  </c:pt>
-                  <c:pt idx="1">
-                    <c:v>Nov 24</c:v>
-                  </c:pt>
-                  <c:pt idx="2">
-                    <c:v>Dec 24</c:v>
-                  </c:pt>
-                  <c:pt idx="3">
-                    <c:v>Jan 25</c:v>
-                  </c:pt>
-                  <c:pt idx="4">
-                    <c:v>Feb 25</c:v>
-                  </c:pt>
-                  <c:pt idx="5">
-                    <c:v>Mar 25</c:v>
-                  </c:pt>
-                  <c:pt idx="6">
-                    <c:v>Apr 25</c:v>
-                  </c:pt>
-                  <c:pt idx="7">
-                    <c:v>May 25</c:v>
-                  </c:pt>
-                  <c:pt idx="8">
-                    <c:v>Jun 25</c:v>
-                  </c:pt>
-                  <c:pt idx="9">
-                    <c:v>Jul 25</c:v>
-                  </c:pt>
-                  <c:pt idx="10">
-                    <c:v>Aug 25</c:v>
-                  </c:pt>
-                  <c:pt idx="11">
-                    <c:v>Sep 25</c:v>
-                  </c:pt>
-                  <c:pt idx="12">
-                    <c:v>Oct 25</c:v>
-                  </c:pt>
-                  <c:pt idx="13">
-                    <c:v>Nov 25</c:v>
-                  </c:pt>
-                  <c:pt idx="14">
-                    <c:v>Dec 25</c:v>
-                  </c:pt>
-                  <c:pt idx="15">
-                    <c:v>Jan 26</c:v>
-                  </c:pt>
-                  <c:pt idx="16">
-                    <c:v>Feb 26</c:v>
-                  </c:pt>
-                  <c:pt idx="17">
-                    <c:v>Mar 26</c:v>
-                  </c:pt>
-                  <c:pt idx="18">
-                    <c:v>Apr 26</c:v>
-                  </c:pt>
-                  <c:pt idx="19">
-                    <c:v>May 26</c:v>
-                  </c:pt>
-                  <c:pt idx="20">
-                    <c:v>Jun 26</c:v>
-                  </c:pt>
-                  <c:pt idx="21">
-                    <c:v>Jul 26</c:v>
-                  </c:pt>
-                  <c:pt idx="22">
-                    <c:v>Aug 26</c:v>
-                  </c:pt>
-                  <c:pt idx="23">
-                    <c:v>Sep 26</c:v>
-                  </c:pt>
-                  <c:pt idx="24">
-                    <c:v>Oct 26</c:v>
-                  </c:pt>
-                  <c:pt idx="25">
-                    <c:v>Nov 26</c:v>
-                  </c:pt>
-                  <c:pt idx="26">
-                    <c:v>Dec 26</c:v>
-                  </c:pt>
-                </c:lvl>
-              </c:multiLvlStrCache>
-            </c:multiLvlStrRef>
-          </c:cat>
-          <c:val>
-            <c:numRef>
-              <c:f>Sheet1!$F$2:$F$28</c:f>
-              <c:numCache>
-                <c:formatCode>General</c:formatCode>
-                <c:ptCount val="27"/>
-                <c:pt idx="0">
-                  <c:v>2.0055825493642043</c:v>
-                </c:pt>
-                <c:pt idx="1">
-                  <c:v>2.2455556710676783</c:v>
-                </c:pt>
-                <c:pt idx="2">
-                  <c:v>2.4286455630513792</c:v>
-                </c:pt>
-                <c:pt idx="3">
-                  <c:v>2.5208333333333277</c:v>
-                </c:pt>
-                <c:pt idx="4">
-                  <c:v>2.3188405797101463</c:v>
-                </c:pt>
-                <c:pt idx="5">
-                  <c:v>2.17815678619131</c:v>
-                </c:pt>
-                <c:pt idx="6">
-                  <c:v>2.1656961896005855</c:v>
-                </c:pt>
-                <c:pt idx="7">
-                  <c:v>1.8960244648318136</c:v>
-                </c:pt>
-                <c:pt idx="8">
-                  <c:v>1.9835215135795004</c:v>
-                </c:pt>
-                <c:pt idx="9">
-                  <c:v>2.0347949944043098</c:v>
-                </c:pt>
-                <c:pt idx="10">
-                  <c:v>2.042267831741529</c:v>
-                </c:pt>
-                <c:pt idx="11">
-                  <c:v>2.2271941421743158</c:v>
-                </c:pt>
-                <c:pt idx="12">
-                  <c:v>2.0979020979020824</c:v>
-                </c:pt>
-                <c:pt idx="13">
-                  <c:v>2.135231316725994</c:v>
-                </c:pt>
-                <c:pt idx="14">
-                  <c:v>1.9657513425878959</c:v>
-                </c:pt>
-                <c:pt idx="15">
-                  <c:v>1.6764885185937661</c:v>
-                </c:pt>
-                <c:pt idx="16">
-                  <c:v>1.8919465803318491</c:v>
-                </c:pt>
-                <c:pt idx="17">
-                  <c:v>2.554047259929604</c:v>
-                </c:pt>
-                <c:pt idx="18">
-                  <c:v>3.029697030296963</c:v>
-                </c:pt>
-                <c:pt idx="19">
-                  <c:v>3.171268507402969</c:v>
-                </c:pt>
-                <c:pt idx="20">
-                  <c:v>2.752842609216022</c:v>
-                </c:pt>
-                <c:pt idx="21">
-                  <c:v>2.9414697377604826</c:v>
-                </c:pt>
-                <c:pt idx="22">
-                  <c:v>3.2460420193169304</c:v>
-                </c:pt>
-                <c:pt idx="23">
-                  <c:v>3.7703939514524443</c:v>
-                </c:pt>
-              </c:numCache>
-            </c:numRef>
-          </c:val>
-          <c:smooth val="0"/>
-        </c:ser>
-        <c:ser>
-          <c:idx val="5"/>
-          <c:order val="5"/>
-          <c:tx>
-            <c:strRef>
-              <c:f>Sheet1!$G$1</c:f>
-              <c:strCache>
-                <c:ptCount val="1"/>
-                <c:pt idx="0">
-                  <c:v>Forecast</c:v>
-                </c:pt>
-              </c:strCache>
-            </c:strRef>
-          </c:tx>
-          <c:spPr>
-            <a:solidFill>
-              <a:srgbClr val="2A78D6"/>
-            </a:solidFill>
-            <a:ln w="28575" cap="flat">
-              <a:solidFill>
-                <a:srgbClr val="2A78D6"/>
-              </a:solidFill>
-              <a:prstDash val="solid"/>
-              <a:round/>
-            </a:ln>
-            <a:effectLst/>
-          </c:spPr>
-          <c:invertIfNegative val="0"/>
-          <c:dLbls>
-            <c:numFmt formatCode="#,##0" sourceLinked="0"/>
-            <c:txPr>
-              <a:bodyPr/>
-              <a:lstStyle/>
-              <a:p>
-                <a:pPr>
-                  <a:defRPr b="0" i="0" strike="noStrike" sz="1200" u="none">
-                    <a:solidFill>
-                      <a:srgbClr val="000000"/>
-                    </a:solidFill>
-                    <a:latin typeface="+mn-lt"/>
-                  </a:defRPr>
-                </a:pPr>
-              </a:p>
-            </c:txPr>
-            <c:showLegendKey val="0"/>
-            <c:showVal val="0"/>
-            <c:showCatName val="0"/>
-            <c:showSerName val="0"/>
-            <c:showPercent val="0"/>
-            <c:showBubbleSize val="0"/>
-            <c:showLeaderLines val="0"/>
-          </c:dLbls>
-          <c:marker>
-            <c:symbol val="none"/>
-            <c:size val="6"/>
-            <c:spPr>
-              <a:solidFill>
-                <a:srgbClr val="2A78D6"/>
-              </a:solidFill>
-              <a:ln w="9525" cap="flat">
-                <a:solidFill>
-                  <a:srgbClr val="2A78D6"/>
-                </a:solidFill>
-                <a:prstDash val="solid"/>
-                <a:round/>
-              </a:ln>
-              <a:effectLst/>
-            </c:spPr>
-          </c:marker>
-          <c:cat>
-            <c:multiLvlStrRef>
-              <c:f>Sheet1!$A$2:$A$28</c:f>
-              <c:multiLvlStrCache>
-                <c:ptCount val="27"/>
-                <c:lvl>
-                  <c:pt idx="0">
-                    <c:v>Oct 24</c:v>
-                  </c:pt>
-                  <c:pt idx="1">
-                    <c:v>Nov 24</c:v>
-                  </c:pt>
-                  <c:pt idx="2">
-                    <c:v>Dec 24</c:v>
-                  </c:pt>
-                  <c:pt idx="3">
-                    <c:v>Jan 25</c:v>
-                  </c:pt>
-                  <c:pt idx="4">
-                    <c:v>Feb 25</c:v>
-                  </c:pt>
-                  <c:pt idx="5">
-                    <c:v>Mar 25</c:v>
-                  </c:pt>
-                  <c:pt idx="6">
-                    <c:v>Apr 25</c:v>
-                  </c:pt>
-                  <c:pt idx="7">
-                    <c:v>May 25</c:v>
-                  </c:pt>
-                  <c:pt idx="8">
-                    <c:v>Jun 25</c:v>
-                  </c:pt>
-                  <c:pt idx="9">
-                    <c:v>Jul 25</c:v>
-                  </c:pt>
-                  <c:pt idx="10">
-                    <c:v>Aug 25</c:v>
-                  </c:pt>
-                  <c:pt idx="11">
-                    <c:v>Sep 25</c:v>
-                  </c:pt>
-                  <c:pt idx="12">
-                    <c:v>Oct 25</c:v>
-                  </c:pt>
-                  <c:pt idx="13">
-                    <c:v>Nov 25</c:v>
-                  </c:pt>
-                  <c:pt idx="14">
-                    <c:v>Dec 25</c:v>
-                  </c:pt>
-                  <c:pt idx="15">
-                    <c:v>Jan 26</c:v>
-                  </c:pt>
-                  <c:pt idx="16">
-                    <c:v>Feb 26</c:v>
-                  </c:pt>
-                  <c:pt idx="17">
-                    <c:v>Mar 26</c:v>
-                  </c:pt>
-                  <c:pt idx="18">
-                    <c:v>Apr 26</c:v>
-                  </c:pt>
-                  <c:pt idx="19">
-                    <c:v>May 26</c:v>
-                  </c:pt>
-                  <c:pt idx="20">
-                    <c:v>Jun 26</c:v>
-                  </c:pt>
-                  <c:pt idx="21">
-                    <c:v>Jul 26</c:v>
-                  </c:pt>
-                  <c:pt idx="22">
-                    <c:v>Aug 26</c:v>
-                  </c:pt>
-                  <c:pt idx="23">
-                    <c:v>Sep 26</c:v>
-                  </c:pt>
-                  <c:pt idx="24">
-                    <c:v>Oct 26</c:v>
-                  </c:pt>
-                  <c:pt idx="25">
-                    <c:v>Nov 26</c:v>
-                  </c:pt>
-                  <c:pt idx="26">
-                    <c:v>Dec 26</c:v>
-                  </c:pt>
-                </c:lvl>
-              </c:multiLvlStrCache>
-            </c:multiLvlStrRef>
-          </c:cat>
-          <c:val>
-            <c:numRef>
-              <c:f>Sheet1!$G$2:$G$28</c:f>
-              <c:numCache>
-                <c:formatCode>General</c:formatCode>
-                <c:ptCount val="27"/>
-                <c:pt idx="23">
-                  <c:v>3.7703939514524443</c:v>
-                </c:pt>
-                <c:pt idx="24">
-                  <c:v>3.778144269083472</c:v>
-                </c:pt>
-                <c:pt idx="25">
-                  <c:v>3.6895580856292742</c:v>
-                </c:pt>
-                <c:pt idx="26">
-                  <c:v>3.7735759028955096</c:v>
-                </c:pt>
-              </c:numCache>
-            </c:numRef>
-          </c:val>
-          <c:smooth val="0"/>
-        </c:ser>
-        <c:dLbls>
-          <c:numFmt formatCode="#,##0" sourceLinked="0"/>
-          <c:txPr>
-            <a:bodyPr/>
-            <a:lstStyle/>
-            <a:p>
-              <a:pPr>
-                <a:defRPr b="0" i="0" strike="noStrike" sz="1200" u="none">
-                  <a:solidFill>
-                    <a:srgbClr val="000000"/>
-                  </a:solidFill>
-                  <a:latin typeface="+mn-lt"/>
-                </a:defRPr>
-              </a:pPr>
-            </a:p>
-          </c:txPr>
-          <c:showLegendKey val="0"/>
-          <c:showVal val="0"/>
-          <c:showCatName val="0"/>
-          <c:showSerName val="0"/>
-          <c:showPercent val="0"/>
-          <c:showBubbleSize val="0"/>
-          <c:showLeaderLines val="0"/>
-        </c:dLbls>
-        <c:marker val="1"/>
-        <c:axId val="2094734554"/>
-        <c:axId val="2094734552"/>
-        <c:axId val="2094734556"/>
-      </c:lineChart>
-      <c:catAx>
-        <c:axId val="2094734554"/>
-        <c:scaling>
-          <c:orientation val="minMax"/>
-        </c:scaling>
-        <c:delete val="0"/>
-        <c:axPos val="b"/>
-        <c:numFmt formatCode="General" sourceLinked="1"/>
-        <c:majorTickMark val="out"/>
-        <c:minorTickMark val="none"/>
-        <c:tickLblPos val="low"/>
-        <c:spPr>
-          <a:ln w="12700" cap="flat">
-            <a:solidFill>
-              <a:srgbClr val="888888"/>
-            </a:solidFill>
-            <a:prstDash val="solid"/>
-            <a:round/>
-          </a:ln>
-        </c:spPr>
-        <c:txPr>
-          <a:bodyPr/>
-          <a:lstStyle/>
-          <a:p>
-            <a:pPr>
-              <a:defRPr sz="1000" b="0" i="0" u="none" strike="noStrike">
-                <a:solidFill>
-                  <a:srgbClr val="5B6B82"/>
-                </a:solidFill>
-                <a:latin typeface="+mn-lt"/>
-              </a:defRPr>
-            </a:pPr>
-            <a:endParaRPr lang="en-US"/>
-          </a:p>
-        </c:txPr>
-        <c:crossAx val="2094734552"/>
-        <c:crosses val="autoZero"/>
-        <c:auto val="1"/>
-        <c:lblAlgn val="ctr"/>
-        <c:noMultiLvlLbl val="1"/>
-        <c:tickLblSkip val="3"/>
-      </c:catAx>
-      <c:valAx>
-        <c:axId val="2094734552"/>
-        <c:scaling>
-          <c:orientation val="minMax"/>
-          <c:max val="5.5"/>
-          <c:min val="1"/>
-        </c:scaling>
-        <c:delete val="0"/>
-        <c:axPos val="l"/>
-        <c:numFmt formatCode="0.0" sourceLinked="0"/>
-        <c:majorTickMark val="out"/>
-        <c:minorTickMark val="none"/>
-        <c:tickLblPos val="nextTo"/>
-        <c:spPr>
-          <a:ln w="12700" cap="flat">
-            <a:solidFill>
-              <a:srgbClr val="888888"/>
-            </a:solidFill>
-            <a:prstDash val="solid"/>
-            <a:round/>
-          </a:ln>
-        </c:spPr>
-        <c:txPr>
-          <a:bodyPr/>
-          <a:lstStyle/>
-          <a:p>
-            <a:pPr>
-              <a:defRPr sz="1100" b="0" i="0" u="none" strike="noStrike">
-                <a:solidFill>
-                  <a:srgbClr val="5B6B82"/>
-                </a:solidFill>
-                <a:latin typeface="+mn-lt"/>
-              </a:defRPr>
-            </a:pPr>
-            <a:endParaRPr lang="en-US"/>
-          </a:p>
-        </c:txPr>
-        <c:crossAx val="2094734554"/>
-        <c:crosses val="autoZero"/>
-        <c:crossBetween val="midCat"/>
-      </c:valAx>
-      <c:spPr>
-        <a:noFill/>
-        <a:ln>
-          <a:noFill/>
-        </a:ln>
-        <a:effectLst/>
-      </c:spPr>
-    </c:plotArea>
-    <c:plotVisOnly val="1"/>
-    <c:dispBlanksAs val="gap"/>
-  </c:chart>
-  <c:spPr>
-    <a:noFill/>
-    <a:ln>
-      <a:noFill/>
-    </a:ln>
-    <a:effectLst/>
-  </c:spPr>
-  <c:externalData r:id="rId1">
-    <c:autoUpdate val="0"/>
-  </c:externalData>
-</c:chartSpace>
-</file>
-
-<file path=ppt/charts/chart2.xml><?xml version="1.0" encoding="utf-8"?>
 <c:chartSpace xmlns:c="http://schemas.openxmlformats.org/drawingml/2006/chart" xmlns:a="http://schemas.openxmlformats.org/drawingml/2006/main" xmlns:r="http://schemas.openxmlformats.org/officeDocument/2006/relationships">
   <c:date1904 val="0"/>
   <c:roundedCorners val="1"/>
@@ -2069,7 +517,7 @@
 </c:chartSpace>
 </file>
 
-<file path=ppt/charts/chart3.xml><?xml version="1.0" encoding="utf-8"?>
+<file path=ppt/charts/chart2.xml><?xml version="1.0" encoding="utf-8"?>
 <c:chartSpace xmlns:c="http://schemas.openxmlformats.org/drawingml/2006/chart" xmlns:a="http://schemas.openxmlformats.org/drawingml/2006/main" xmlns:r="http://schemas.openxmlformats.org/officeDocument/2006/relationships">
   <c:date1904 val="0"/>
   <c:roundedCorners val="1"/>
@@ -3080,7 +1528,7 @@
             <a:r>
               <a:rPr lang="en-US" dirty="0"/>
               <a:t>One preset, with its assumptions on screen. Wholesale gas spikes; retail gas and electricity follow slowly because of regulated tariffs and fixed contracts, so the shock is +20% on the retail level, phased in over 6 months from Nov 2026, about a quarter of the 2021-22 episode.
-The engine moves each country and component's price level and re-aggregates with the euro area weights, so the pass-through is exact arithmetic rather than a regression: the impact builds to +1.07 pp in Apr 2027, and December would print 4.1% instead of 3.8%. Because it is a level shock, it lifts y/y for a year and then drops out as a base effect.
+The engine moves each country and component's price level and re-aggregates with the euro area weights, so the pass-through is exact arithmetic rather than a regression: the impact builds to +1.07 pp in Apr 2027, and December would print 4.1% instead of 3.8%. Each step of the price increase affects y/y for twelve months and then drops out as a base effect, which is why the impact plateaus and then falls from Nov 2027.
 The assumptions (A1 to A5) are always visible next to the result. Second-round effects into core are optional, estimated with a regime-dependent distributed lag, and shown separately because they are uncertain.
 For oil, the Brent preset goes through an estimated pass-through to fuel prices of 0.31 (s.e. 0.04); +30% Brent peaks at +0.46 pp. The simulator also solves backwards: what size of shock takes December to a target.</a:t>
             </a:r>
@@ -4346,11 +2794,11 @@
         <p:spPr>
           <a:xfrm>
             <a:off x="5349240" y="1783080"/>
-            <a:ext cx="6291072" cy="4343400"/>
+            <a:ext cx="6291072" cy="4206240"/>
           </a:xfrm>
           <a:prstGeom prst="roundRect">
             <a:avLst>
-              <a:gd name="adj" fmla="val 2526"/>
+              <a:gd name="adj" fmla="val 2609"/>
             </a:avLst>
           </a:prstGeom>
           <a:solidFill>
@@ -4364,31 +2812,39 @@
           </a:ln>
         </p:spPr>
       </p:sp>
-      <p:graphicFrame>
-        <p:nvGraphicFramePr>
-          <p:cNvPr id="16" name="headline forecast chart" descr=""/>
-          <p:cNvGraphicFramePr/>
-          <p:nvPr/>
-        </p:nvGraphicFramePr>
-        <p:xfrm>
-          <a:off x="5486400" y="1874520"/>
-          <a:ext cx="6035040" cy="3749040"/>
-        </p:xfrm>
-        <a:graphic xmlns:a="http://schemas.openxmlformats.org/drawingml/2006/main">
-          <a:graphicData uri="http://schemas.openxmlformats.org/drawingml/2006/chart">
-            <c:chart xmlns:c="http://schemas.openxmlformats.org/drawingml/2006/chart" r:id="rId1"/>
-          </a:graphicData>
-        </a:graphic>
-      </p:graphicFrame>
-      <p:sp>
-        <p:nvSpPr>
-          <p:cNvPr id="17" name="chart key"/>
+      <p:pic>
+        <p:nvPicPr>
+          <p:cNvPr id="16" name="headline forecast fan" descr="Headline HICP y/y over the last 24 months and the forecast to Dec 2026: 3.77%, 68% band 3.4–4.2%, 90% band 3.0–5.1%.">    </p:cNvPr>
+          <p:cNvPicPr>
+            <a:picLocks noChangeAspect="1"/>
+          </p:cNvPicPr>
+          <p:nvPr/>
+        </p:nvPicPr>
+        <p:blipFill>
+          <a:blip r:embed="rId1"/>
+          <a:stretch>
+            <a:fillRect/>
+          </a:stretch>
+        </p:blipFill>
+        <p:spPr>
+          <a:xfrm>
+            <a:off x="5504688" y="1938528"/>
+            <a:ext cx="5980176" cy="3534156"/>
+          </a:xfrm>
+          <a:prstGeom prst="rect">
+            <a:avLst/>
+          </a:prstGeom>
+        </p:spPr>
+      </p:pic>
+      <p:sp>
+        <p:nvSpPr>
+          <p:cNvPr id="17" name="chart note"/>
           <p:cNvSpPr txBox="1"/>
           <p:nvPr/>
         </p:nvSpPr>
         <p:spPr>
           <a:xfrm>
-            <a:off x="5715000" y="5650992"/>
+            <a:off x="5669280" y="5532120"/>
             <a:ext cx="5760720" cy="320040"/>
           </a:xfrm>
           <a:prstGeom prst="rect">
@@ -4405,91 +2861,14 @@
               <a:buNone/>
             </a:pPr>
             <a:r>
-              <a:rPr lang="en-US" sz="1200" b="1" dirty="0">
-                <a:solidFill>
-                  <a:srgbClr val="0F1B2D"/>
-                </a:solidFill>
-              </a:rPr>
-              <a:t>Actual</a:t>
-            </a:r>
-            <a:pPr indent="0" marL="0">
-              <a:buNone/>
-            </a:pPr>
-            <a:r>
-              <a:rPr lang="en-US" sz="1200" dirty="0">
-                <a:solidFill>
-                  <a:schemeClr val="tx1"/>
-                </a:solidFill>
-              </a:rPr>
-              <a:t>   </a:t>
-            </a:r>
-            <a:pPr indent="0" marL="0">
-              <a:buNone/>
-            </a:pPr>
-            <a:r>
-              <a:rPr lang="en-US" sz="1200" b="1" dirty="0">
-                <a:solidFill>
-                  <a:srgbClr val="2A78D6"/>
-                </a:solidFill>
-              </a:rPr>
-              <a:t>Forecast</a:t>
-            </a:r>
-            <a:pPr indent="0" marL="0">
-              <a:buNone/>
-            </a:pPr>
-            <a:r>
-              <a:rPr lang="en-US" sz="1200" dirty="0">
-                <a:solidFill>
-                  <a:schemeClr val="tx1"/>
-                </a:solidFill>
-              </a:rPr>
-              <a:t>   </a:t>
-            </a:r>
-            <a:pPr indent="0" marL="0">
-              <a:buNone/>
-            </a:pPr>
-            <a:r>
-              <a:rPr lang="en-US" sz="1200" b="1" dirty="0">
-                <a:solidFill>
-                  <a:srgbClr val="6F9FDB"/>
-                </a:solidFill>
-              </a:rPr>
-              <a:t>68% band</a:t>
-            </a:r>
-            <a:pPr indent="0" marL="0">
-              <a:buNone/>
-            </a:pPr>
-            <a:r>
-              <a:rPr lang="en-US" sz="1200" dirty="0">
-                <a:solidFill>
-                  <a:schemeClr val="tx1"/>
-                </a:solidFill>
-              </a:rPr>
-              <a:t>   </a:t>
-            </a:r>
-            <a:pPr indent="0" marL="0">
-              <a:buNone/>
-            </a:pPr>
-            <a:r>
-              <a:rPr lang="en-US" sz="1200" b="1" dirty="0">
-                <a:solidFill>
-                  <a:srgbClr val="9DB9DE"/>
-                </a:solidFill>
-              </a:rPr>
-              <a:t>90% band</a:t>
-            </a:r>
-            <a:pPr indent="0" marL="0">
-              <a:buNone/>
-            </a:pPr>
-            <a:r>
-              <a:rPr lang="en-US" sz="1200" dirty="0">
-                <a:solidFill>
-                  <a:srgbClr val="5B6B82"/>
-                </a:solidFill>
-              </a:rPr>
-              <a:t>   (from past forecast errors)</a:t>
-            </a:r>
-            <a:endParaRPr lang="en-US" sz="1200" dirty="0"/>
+              <a:rPr lang="en-US" sz="1100" dirty="0">
+                <a:solidFill>
+                  <a:schemeClr val="accent3"/>
+                </a:solidFill>
+              </a:rPr>
+              <a:t>Bands from the model's own past out-of-sample errors</a:t>
+            </a:r>
+            <a:endParaRPr lang="en-US" sz="1100" dirty="0"/>
           </a:p>
         </p:txBody>
       </p:sp>
@@ -6743,7 +5122,7 @@
                   <a:schemeClr val="accent3"/>
                 </a:solidFill>
               </a:rPr>
-              <a:t>A permanent shock lifts y/y for 12 months, then drops out</a:t>
+              <a:t>Each price increment affects y/y for 12 months</a:t>
             </a:r>
             <a:endParaRPr lang="en-US" sz="1200" dirty="0"/>
           </a:p>

</xml_diff>